<commit_message>
Update SRIB manager effectiveness deck scope
</commit_message>
<xml_diff>
--- a/documentation/manager-effectiveness-everyday-leadership.pptx
+++ b/documentation/manager-effectiveness-everyday-leadership.pptx
@@ -2,17 +2,17 @@
 <file path=ppt/presentation.xml><?xml version="1.0" encoding="utf-8"?>
 <p:presentation xmlns:p="http://schemas.openxmlformats.org/presentationml/2006/main">
   <p:sldMasterIdLst>
-    <p:sldMasterId xmlns:r="http://schemas.openxmlformats.org/officeDocument/2006/relationships" id="2147483648" r:id="R32e278b4e3984392"/>
+    <p:sldMasterId xmlns:r="http://schemas.openxmlformats.org/officeDocument/2006/relationships" id="2147483648" r:id="R33a796125c8e43d4"/>
   </p:sldMasterIdLst>
   <p:notesMasterIdLst>
-    <p:notesMasterId xmlns:r="http://schemas.openxmlformats.org/officeDocument/2006/relationships" r:id="R022fa9255a994d75"/>
+    <p:notesMasterId xmlns:r="http://schemas.openxmlformats.org/officeDocument/2006/relationships" r:id="R2710999fd9684efe"/>
   </p:notesMasterIdLst>
   <p:sldIdLst>
-    <p:sldId xmlns:r="http://schemas.openxmlformats.org/officeDocument/2006/relationships" id="256" r:id="R6ebf341eca024cd5"/>
-    <p:sldId xmlns:r="http://schemas.openxmlformats.org/officeDocument/2006/relationships" id="257" r:id="Rfcd418d9dff64c11"/>
-    <p:sldId xmlns:r="http://schemas.openxmlformats.org/officeDocument/2006/relationships" id="258" r:id="R8b6d1914469a4b4c"/>
-    <p:sldId xmlns:r="http://schemas.openxmlformats.org/officeDocument/2006/relationships" id="259" r:id="R065f66801a974b3b"/>
-    <p:sldId xmlns:r="http://schemas.openxmlformats.org/officeDocument/2006/relationships" id="260" r:id="R553f124c505b433c"/>
+    <p:sldId xmlns:r="http://schemas.openxmlformats.org/officeDocument/2006/relationships" id="256" r:id="R6e4287c04bf3436f"/>
+    <p:sldId xmlns:r="http://schemas.openxmlformats.org/officeDocument/2006/relationships" id="257" r:id="Rb8b3b496c63b41c0"/>
+    <p:sldId xmlns:r="http://schemas.openxmlformats.org/officeDocument/2006/relationships" id="258" r:id="R7caf978c88f9444a"/>
+    <p:sldId xmlns:r="http://schemas.openxmlformats.org/officeDocument/2006/relationships" id="259" r:id="R22a18e1d3c034dc3"/>
+    <p:sldId xmlns:r="http://schemas.openxmlformats.org/officeDocument/2006/relationships" id="260" r:id="R3f3cc4b4d20b4a93"/>
   </p:sldIdLst>
   <p:sldSz cx="12192000" cy="6858000"/>
   <p:notesSz cx="6858000" cy="9144000"/>
@@ -823,7 +823,7 @@
   </p:cSld>
   <p:clrMap bg1="lt1" tx1="dk1" bg2="lt2" tx2="dk2" accent1="accent1" accent2="accent2" accent3="accent3" accent4="accent4" accent5="accent5" accent6="accent6" hlink="hlink" folHlink="folHlink"/>
   <p:sldLayoutIdLst>
-    <p:sldLayoutId xmlns:r="http://schemas.openxmlformats.org/officeDocument/2006/relationships" id="2147483649" r:id="R7f2a6f7dedad42ed"/>
+    <p:sldLayoutId xmlns:r="http://schemas.openxmlformats.org/officeDocument/2006/relationships" id="2147483649" r:id="R2224d35756104bc8"/>
   </p:sldLayoutIdLst>
   <p:txStyles>
     <p:titleStyle>
@@ -1129,7 +1129,7 @@
           <p:cNvPr id="1" name="">
             <a:extLst xmlns:a="http://schemas.openxmlformats.org/drawingml/2006/main">
               <a:ext uri="{FF2B5EF4-FFF2-40B4-BE49-F238E27FC236}">
-                <a16:creationId xmlns:a16="http://schemas.microsoft.com/office/drawing/2014/main" id="{4EAD01FD-03FA-4EE5-8564-BC43D379B4E0}"/>
+                <a16:creationId xmlns:a16="http://schemas.microsoft.com/office/drawing/2014/main" id="{60B05E67-E35E-4557-9E3B-4E5BF21D0D98}"/>
               </a:ext>
             </a:extLst>
           </p:cNvPr>
@@ -1156,7 +1156,7 @@
           <p:cNvPr id="2" name="">
             <a:extLst xmlns:a="http://schemas.openxmlformats.org/drawingml/2006/main">
               <a:ext uri="{FF2B5EF4-FFF2-40B4-BE49-F238E27FC236}">
-                <a16:creationId xmlns:a16="http://schemas.microsoft.com/office/drawing/2014/main" id="{28CDC1A7-7115-4075-A86D-9D4E87FFD796}"/>
+                <a16:creationId xmlns:a16="http://schemas.microsoft.com/office/drawing/2014/main" id="{A8CF9D65-3A1F-4089-B836-E9F3401ED093}"/>
               </a:ext>
             </a:extLst>
           </p:cNvPr>
@@ -1183,7 +1183,7 @@
           <p:cNvPr id="3" name="">
             <a:extLst xmlns:a="http://schemas.openxmlformats.org/drawingml/2006/main">
               <a:ext uri="{FF2B5EF4-FFF2-40B4-BE49-F238E27FC236}">
-                <a16:creationId xmlns:a16="http://schemas.microsoft.com/office/drawing/2014/main" id="{5CCBE8F4-45D4-484D-8214-22BB7EBB4FCE}"/>
+                <a16:creationId xmlns:a16="http://schemas.microsoft.com/office/drawing/2014/main" id="{4735928C-17E5-463A-A1CB-19ED984E7F37}"/>
               </a:ext>
             </a:extLst>
           </p:cNvPr>
@@ -1212,7 +1212,7 @@
           <p:cNvPr id="4" name="">
             <a:extLst xmlns:a="http://schemas.openxmlformats.org/drawingml/2006/main">
               <a:ext uri="{FF2B5EF4-FFF2-40B4-BE49-F238E27FC236}">
-                <a16:creationId xmlns:a16="http://schemas.microsoft.com/office/drawing/2014/main" id="{2D3876D5-6524-4477-9D27-B1E6C726029F}"/>
+                <a16:creationId xmlns:a16="http://schemas.microsoft.com/office/drawing/2014/main" id="{D441C8DA-FA28-45D3-9815-ADFD9B525333}"/>
               </a:ext>
             </a:extLst>
           </p:cNvPr>
@@ -1241,7 +1241,7 @@
           <p:cNvPr id="5" name="">
             <a:extLst xmlns:a="http://schemas.openxmlformats.org/drawingml/2006/main">
               <a:ext uri="{FF2B5EF4-FFF2-40B4-BE49-F238E27FC236}">
-                <a16:creationId xmlns:a16="http://schemas.microsoft.com/office/drawing/2014/main" id="{7D774AB9-B5B6-4AA8-B259-081F48808E4B}"/>
+                <a16:creationId xmlns:a16="http://schemas.microsoft.com/office/drawing/2014/main" id="{01250539-7CAC-48D5-922E-DD35571453FF}"/>
               </a:ext>
             </a:extLst>
           </p:cNvPr>
@@ -1270,7 +1270,7 @@
           <p:cNvPr id="6" name="">
             <a:extLst xmlns:a="http://schemas.openxmlformats.org/drawingml/2006/main">
               <a:ext uri="{FF2B5EF4-FFF2-40B4-BE49-F238E27FC236}">
-                <a16:creationId xmlns:a16="http://schemas.microsoft.com/office/drawing/2014/main" id="{B82C6E98-D2F2-4E79-9990-3ACB41A7AECE}"/>
+                <a16:creationId xmlns:a16="http://schemas.microsoft.com/office/drawing/2014/main" id="{1DD99FFB-33EF-481D-B342-69CDDE84EA3D}"/>
               </a:ext>
             </a:extLst>
           </p:cNvPr>
@@ -1315,7 +1315,7 @@
           <p:cNvPr id="7" name="">
             <a:extLst xmlns:a="http://schemas.openxmlformats.org/drawingml/2006/main">
               <a:ext uri="{FF2B5EF4-FFF2-40B4-BE49-F238E27FC236}">
-                <a16:creationId xmlns:a16="http://schemas.microsoft.com/office/drawing/2014/main" id="{C1BAFE69-5E19-4EAD-A115-A0F1FD4E7E37}"/>
+                <a16:creationId xmlns:a16="http://schemas.microsoft.com/office/drawing/2014/main" id="{52FDA4AB-4402-4721-AE21-C6DB17389CE6}"/>
               </a:ext>
             </a:extLst>
           </p:cNvPr>
@@ -1360,7 +1360,7 @@
           <p:cNvPr id="8" name="">
             <a:extLst xmlns:a="http://schemas.openxmlformats.org/drawingml/2006/main">
               <a:ext uri="{FF2B5EF4-FFF2-40B4-BE49-F238E27FC236}">
-                <a16:creationId xmlns:a16="http://schemas.microsoft.com/office/drawing/2014/main" id="{89612867-84C4-4549-B5B8-3518D92D217E}"/>
+                <a16:creationId xmlns:a16="http://schemas.microsoft.com/office/drawing/2014/main" id="{568D8EF4-DF8B-4380-8899-13B3FF7A1D28}"/>
               </a:ext>
             </a:extLst>
           </p:cNvPr>
@@ -1405,7 +1405,7 @@
           <p:cNvPr id="9" name="">
             <a:extLst xmlns:a="http://schemas.openxmlformats.org/drawingml/2006/main">
               <a:ext uri="{FF2B5EF4-FFF2-40B4-BE49-F238E27FC236}">
-                <a16:creationId xmlns:a16="http://schemas.microsoft.com/office/drawing/2014/main" id="{76B7B9B4-F08F-40CA-8A62-3E083452EBDE}"/>
+                <a16:creationId xmlns:a16="http://schemas.microsoft.com/office/drawing/2014/main" id="{5B645506-0755-485B-B1AA-5689698B7B2E}"/>
               </a:ext>
             </a:extLst>
           </p:cNvPr>
@@ -1417,7 +1417,7 @@
         <p:spPr>
           <a:xfrm xmlns:a="http://schemas.openxmlformats.org/drawingml/2006/main">
             <a:off x="552450" y="495300"/>
-            <a:ext cx="1943100" cy="323850"/>
+            <a:ext cx="2362200" cy="323850"/>
           </a:xfrm>
           <a:prstGeom xmlns:a="http://schemas.openxmlformats.org/drawingml/2006/main" prst="roundRect">
             <a:avLst>
@@ -1434,7 +1434,7 @@
           <p:cNvPr id="10" name="">
             <a:extLst xmlns:a="http://schemas.openxmlformats.org/drawingml/2006/main">
               <a:ext uri="{FF2B5EF4-FFF2-40B4-BE49-F238E27FC236}">
-                <a16:creationId xmlns:a16="http://schemas.microsoft.com/office/drawing/2014/main" id="{79876171-FFB4-459D-B096-ED4C464FF9DC}"/>
+                <a16:creationId xmlns:a16="http://schemas.microsoft.com/office/drawing/2014/main" id="{FA4BF7E3-1C11-446F-BD8A-B9E6523F9834}"/>
               </a:ext>
             </a:extLst>
           </p:cNvPr>
@@ -1446,7 +1446,7 @@
         <p:spPr>
           <a:xfrm xmlns:a="http://schemas.openxmlformats.org/drawingml/2006/main">
             <a:off x="685800" y="571500"/>
-            <a:ext cx="1676400" cy="171450"/>
+            <a:ext cx="2095500" cy="171450"/>
           </a:xfrm>
           <a:prstGeom xmlns:a="http://schemas.openxmlformats.org/drawingml/2006/main" prst="rect">
             <a:avLst/>
@@ -1469,7 +1469,7 @@
               </a:defRPr>
             </a:pPr>
             <a:r>
-              <a:t>LEADERSHIP TASK FORCE</a:t>
+              <a:t>SRI-B LEADERSHIP TASK FORCE</a:t>
             </a:r>
           </a:p>
         </p:txBody>
@@ -1479,7 +1479,7 @@
           <p:cNvPr id="11" name="">
             <a:extLst xmlns:a="http://schemas.openxmlformats.org/drawingml/2006/main">
               <a:ext uri="{FF2B5EF4-FFF2-40B4-BE49-F238E27FC236}">
-                <a16:creationId xmlns:a16="http://schemas.microsoft.com/office/drawing/2014/main" id="{A42FB816-0C29-4C46-8878-81C85D7282A0}"/>
+                <a16:creationId xmlns:a16="http://schemas.microsoft.com/office/drawing/2014/main" id="{CA39CD0D-0E37-4C57-A109-BA75070EFFFE}"/>
               </a:ext>
             </a:extLst>
           </p:cNvPr>
@@ -1524,7 +1524,7 @@
           <p:cNvPr id="12" name="">
             <a:extLst xmlns:a="http://schemas.openxmlformats.org/drawingml/2006/main">
               <a:ext uri="{FF2B5EF4-FFF2-40B4-BE49-F238E27FC236}">
-                <a16:creationId xmlns:a16="http://schemas.microsoft.com/office/drawing/2014/main" id="{2787FA25-D07A-4076-BCA5-633A4728B9E9}"/>
+                <a16:creationId xmlns:a16="http://schemas.microsoft.com/office/drawing/2014/main" id="{7F65B672-9BD3-4D87-B558-EEF69AAFD38B}"/>
               </a:ext>
             </a:extLst>
           </p:cNvPr>
@@ -1559,7 +1559,7 @@
               </a:defRPr>
             </a:pPr>
             <a:r>
-              <a:t>A five-part plan to institutionalize coaching, continuous feedback, manager enablement, and leader-led learning circles across Samsung India.</a:t>
+              <a:t>Plan for Samsung R&amp;D Institute Bangalore managers and employees, running from June 2026 to December 2026.</a:t>
             </a:r>
           </a:p>
         </p:txBody>
@@ -1569,7 +1569,7 @@
           <p:cNvPr id="13" name="">
             <a:extLst xmlns:a="http://schemas.openxmlformats.org/drawingml/2006/main">
               <a:ext uri="{FF2B5EF4-FFF2-40B4-BE49-F238E27FC236}">
-                <a16:creationId xmlns:a16="http://schemas.microsoft.com/office/drawing/2014/main" id="{08FB0384-6A5E-4A20-B151-65662E7ACB04}"/>
+                <a16:creationId xmlns:a16="http://schemas.microsoft.com/office/drawing/2014/main" id="{CA86275F-6527-4D45-90E6-5E4B40D4282D}"/>
               </a:ext>
             </a:extLst>
           </p:cNvPr>
@@ -1598,7 +1598,7 @@
           <p:cNvPr id="14" name="">
             <a:extLst xmlns:a="http://schemas.openxmlformats.org/drawingml/2006/main">
               <a:ext uri="{FF2B5EF4-FFF2-40B4-BE49-F238E27FC236}">
-                <a16:creationId xmlns:a16="http://schemas.microsoft.com/office/drawing/2014/main" id="{639645B4-CB75-4D7D-A95B-042A55AF7844}"/>
+                <a16:creationId xmlns:a16="http://schemas.microsoft.com/office/drawing/2014/main" id="{AF16457E-4042-40C1-9FD5-57E86C1B64BA}"/>
               </a:ext>
             </a:extLst>
           </p:cNvPr>
@@ -1633,7 +1633,7 @@
               </a:defRPr>
             </a:pPr>
             <a:r>
-              <a:t>01</a:t>
+              <a:t>SRIB</a:t>
             </a:r>
           </a:p>
         </p:txBody>
@@ -1643,7 +1643,7 @@
           <p:cNvPr id="15" name="">
             <a:extLst xmlns:a="http://schemas.openxmlformats.org/drawingml/2006/main">
               <a:ext uri="{FF2B5EF4-FFF2-40B4-BE49-F238E27FC236}">
-                <a16:creationId xmlns:a16="http://schemas.microsoft.com/office/drawing/2014/main" id="{E53F5B75-8EA0-4ADF-B695-42BA2CC33B92}"/>
+                <a16:creationId xmlns:a16="http://schemas.microsoft.com/office/drawing/2014/main" id="{AB43DA59-9171-4503-9BBD-F46C2FFD87BD}"/>
               </a:ext>
             </a:extLst>
           </p:cNvPr>
@@ -1663,7 +1663,7 @@
         </p:spPr>
         <p:txBody>
           <a:bodyPr xmlns:a="http://schemas.openxmlformats.org/drawingml/2006/main" lIns="0" tIns="0" rIns="0" bIns="0">
-            <a:normAutofit fontScale="93782"/>
+            <a:normAutofit fontScale="75397"/>
           </a:bodyPr>
           <a:lstStyle xmlns:a="http://schemas.openxmlformats.org/drawingml/2006/main"/>
           <a:p xmlns:a="http://schemas.openxmlformats.org/drawingml/2006/main">
@@ -1678,7 +1678,7 @@
               </a:defRPr>
             </a:pPr>
             <a:r>
-              <a:t>Shift managers from task owners to everyday coaches</a:t>
+              <a:t>Audience: managers, first-time managers, leaders, and employees across teams</a:t>
             </a:r>
           </a:p>
         </p:txBody>
@@ -1688,7 +1688,7 @@
           <p:cNvPr id="16" name="">
             <a:extLst xmlns:a="http://schemas.openxmlformats.org/drawingml/2006/main">
               <a:ext uri="{FF2B5EF4-FFF2-40B4-BE49-F238E27FC236}">
-                <a16:creationId xmlns:a16="http://schemas.microsoft.com/office/drawing/2014/main" id="{9BBD5B6A-F8C4-4360-BFE2-54DC2EA55B27}"/>
+                <a16:creationId xmlns:a16="http://schemas.microsoft.com/office/drawing/2014/main" id="{00A868E1-D6C4-41DE-B119-C35C67321CEB}"/>
               </a:ext>
             </a:extLst>
           </p:cNvPr>
@@ -1717,7 +1717,7 @@
           <p:cNvPr id="17" name="">
             <a:extLst xmlns:a="http://schemas.openxmlformats.org/drawingml/2006/main">
               <a:ext uri="{FF2B5EF4-FFF2-40B4-BE49-F238E27FC236}">
-                <a16:creationId xmlns:a16="http://schemas.microsoft.com/office/drawing/2014/main" id="{080ECBF2-6777-4A89-9DF8-7A69F33DD40F}"/>
+                <a16:creationId xmlns:a16="http://schemas.microsoft.com/office/drawing/2014/main" id="{EBA8F527-06EC-4BE4-8703-52511679277B}"/>
               </a:ext>
             </a:extLst>
           </p:cNvPr>
@@ -1752,7 +1752,7 @@
               </a:defRPr>
             </a:pPr>
             <a:r>
-              <a:t>02</a:t>
+              <a:t>Jun-Dec</a:t>
             </a:r>
           </a:p>
         </p:txBody>
@@ -1762,7 +1762,7 @@
           <p:cNvPr id="18" name="">
             <a:extLst xmlns:a="http://schemas.openxmlformats.org/drawingml/2006/main">
               <a:ext uri="{FF2B5EF4-FFF2-40B4-BE49-F238E27FC236}">
-                <a16:creationId xmlns:a16="http://schemas.microsoft.com/office/drawing/2014/main" id="{67F79027-B25C-4A9F-91C7-BC6EB3170EA4}"/>
+                <a16:creationId xmlns:a16="http://schemas.microsoft.com/office/drawing/2014/main" id="{19CCB213-8003-4566-9A75-266E21A40EBC}"/>
               </a:ext>
             </a:extLst>
           </p:cNvPr>
@@ -1782,7 +1782,7 @@
         </p:spPr>
         <p:txBody>
           <a:bodyPr xmlns:a="http://schemas.openxmlformats.org/drawingml/2006/main" lIns="0" tIns="0" rIns="0" bIns="0">
-            <a:normAutofit fontScale="92468"/>
+            <a:normAutofit fontScale="81061"/>
           </a:bodyPr>
           <a:lstStyle xmlns:a="http://schemas.openxmlformats.org/drawingml/2006/main"/>
           <a:p xmlns:a="http://schemas.openxmlformats.org/drawingml/2006/main">
@@ -1797,7 +1797,7 @@
               </a:defRPr>
             </a:pPr>
             <a:r>
-              <a:t>Make feedback continuous, specific, and psychologically safe</a:t>
+              <a:t>Time horizon: launch in June 2026 and institutionalize by December 2026</a:t>
             </a:r>
           </a:p>
         </p:txBody>
@@ -1807,7 +1807,7 @@
           <p:cNvPr id="19" name="">
             <a:extLst xmlns:a="http://schemas.openxmlformats.org/drawingml/2006/main">
               <a:ext uri="{FF2B5EF4-FFF2-40B4-BE49-F238E27FC236}">
-                <a16:creationId xmlns:a16="http://schemas.microsoft.com/office/drawing/2014/main" id="{D10CD537-E032-4CD2-B38E-A2FAD2ABA44E}"/>
+                <a16:creationId xmlns:a16="http://schemas.microsoft.com/office/drawing/2014/main" id="{F67313B7-832E-44B4-BADA-C3513E7EC1B0}"/>
               </a:ext>
             </a:extLst>
           </p:cNvPr>
@@ -1836,7 +1836,7 @@
           <p:cNvPr id="20" name="">
             <a:extLst xmlns:a="http://schemas.openxmlformats.org/drawingml/2006/main">
               <a:ext uri="{FF2B5EF4-FFF2-40B4-BE49-F238E27FC236}">
-                <a16:creationId xmlns:a16="http://schemas.microsoft.com/office/drawing/2014/main" id="{312381CB-D365-4C20-AF1A-CE45201D507C}"/>
+                <a16:creationId xmlns:a16="http://schemas.microsoft.com/office/drawing/2014/main" id="{4E6A418C-AE73-46BA-B8B1-AA22D732D2E7}"/>
               </a:ext>
             </a:extLst>
           </p:cNvPr>
@@ -1871,7 +1871,7 @@
               </a:defRPr>
             </a:pPr>
             <a:r>
-              <a:t>03</a:t>
+              <a:t>LMD</a:t>
             </a:r>
           </a:p>
         </p:txBody>
@@ -1881,7 +1881,7 @@
           <p:cNvPr id="21" name="">
             <a:extLst xmlns:a="http://schemas.openxmlformats.org/drawingml/2006/main">
               <a:ext uri="{FF2B5EF4-FFF2-40B4-BE49-F238E27FC236}">
-                <a16:creationId xmlns:a16="http://schemas.microsoft.com/office/drawing/2014/main" id="{7291B713-B956-48AE-9FDC-EB384BB5EDAB}"/>
+                <a16:creationId xmlns:a16="http://schemas.microsoft.com/office/drawing/2014/main" id="{3795D136-C4BF-4F62-8B82-529C103B789C}"/>
               </a:ext>
             </a:extLst>
           </p:cNvPr>
@@ -1901,7 +1901,7 @@
         </p:spPr>
         <p:txBody>
           <a:bodyPr xmlns:a="http://schemas.openxmlformats.org/drawingml/2006/main" lIns="0" tIns="0" rIns="0" bIns="0">
-            <a:normAutofit fontScale="100000"/>
+            <a:normAutofit fontScale="95304"/>
           </a:bodyPr>
           <a:lstStyle xmlns:a="http://schemas.openxmlformats.org/drawingml/2006/main"/>
           <a:p xmlns:a="http://schemas.openxmlformats.org/drawingml/2006/main">
@@ -1916,7 +1916,7 @@
               </a:defRPr>
             </a:pPr>
             <a:r>
-              <a:t>Strengthen first-time manager transition with LMD</a:t>
+              <a:t>Partner with LMD for curriculum, toolkits, and transition support</a:t>
             </a:r>
           </a:p>
         </p:txBody>
@@ -1926,7 +1926,7 @@
           <p:cNvPr id="22" name="">
             <a:extLst xmlns:a="http://schemas.openxmlformats.org/drawingml/2006/main">
               <a:ext uri="{FF2B5EF4-FFF2-40B4-BE49-F238E27FC236}">
-                <a16:creationId xmlns:a16="http://schemas.microsoft.com/office/drawing/2014/main" id="{E416EA29-1C51-4413-B5EB-FB9FFA2013AC}"/>
+                <a16:creationId xmlns:a16="http://schemas.microsoft.com/office/drawing/2014/main" id="{A03D7D72-0F28-460F-BEC4-4961A6BD9E1D}"/>
               </a:ext>
             </a:extLst>
           </p:cNvPr>
@@ -1953,15 +1953,15 @@
             <a:pPr>
               <a:defRPr sz="900" b="0">
                 <a:solidFill>
-                  <a:srgbClr val="91A0B8"/>
-                </a:solidFill>
-                <a:latin typeface="Aptos"/>
-                <a:ea typeface="Aptos"/>
-                <a:cs typeface="Aptos"/>
-              </a:defRPr>
-            </a:pPr>
-            <a:r>
-              <a:t>Draft initiative plan for internal discussion</a:t>
+                  <a:srgbClr val="B8C3D5"/>
+                </a:solidFill>
+                <a:latin typeface="Aptos"/>
+                <a:ea typeface="Aptos"/>
+                <a:cs typeface="Aptos"/>
+              </a:defRPr>
+            </a:pPr>
+            <a:r>
+              <a:t>Draft initiative plan for SRIB internal discussion</a:t>
             </a:r>
           </a:p>
         </p:txBody>
@@ -1971,7 +1971,7 @@
           <p:cNvPr id="23" name="">
             <a:extLst xmlns:a="http://schemas.openxmlformats.org/drawingml/2006/main">
               <a:ext uri="{FF2B5EF4-FFF2-40B4-BE49-F238E27FC236}">
-                <a16:creationId xmlns:a16="http://schemas.microsoft.com/office/drawing/2014/main" id="{4CEEA063-FF27-41C9-A33F-3AC69A48A1BA}"/>
+                <a16:creationId xmlns:a16="http://schemas.microsoft.com/office/drawing/2014/main" id="{C72A5B24-BD19-4B45-8984-80689F7A2B41}"/>
               </a:ext>
             </a:extLst>
           </p:cNvPr>
@@ -1983,7 +1983,7 @@
         <p:spPr>
           <a:xfrm xmlns:a="http://schemas.openxmlformats.org/drawingml/2006/main">
             <a:off x="457200" y="6438900"/>
-            <a:ext cx="6858000" cy="171450"/>
+            <a:ext cx="7239000" cy="171450"/>
           </a:xfrm>
           <a:prstGeom xmlns:a="http://schemas.openxmlformats.org/drawingml/2006/main" prst="rect">
             <a:avLst/>
@@ -2006,7 +2006,7 @@
               </a:defRPr>
             </a:pPr>
             <a:r>
-              <a:t>Leadership Task Force | Manager Effectiveness and Everyday Leadership | Samsung India</a:t>
+              <a:t>Samsung R&amp;D Institute Bangalore | SRIB Managers and Employees | June-Dec 2026</a:t>
             </a:r>
           </a:p>
         </p:txBody>
@@ -2014,7 +2014,7 @@
     </p:spTree>
     <p:extLst>
       <p:ext uri="{BB962C8B-B14F-4D97-AF65-F5344CB8AC3E}">
-        <p14:creationId xmlns:p14="http://schemas.microsoft.com/office/powerpoint/2010/main" val="918690628"/>
+        <p14:creationId xmlns:p14="http://schemas.microsoft.com/office/powerpoint/2010/main" val="1899101220"/>
       </p:ext>
     </p:extLst>
   </p:cSld>
@@ -2045,7 +2045,7 @@
           <p:cNvPr id="1" name="">
             <a:extLst xmlns:a="http://schemas.openxmlformats.org/drawingml/2006/main">
               <a:ext uri="{FF2B5EF4-FFF2-40B4-BE49-F238E27FC236}">
-                <a16:creationId xmlns:a16="http://schemas.microsoft.com/office/drawing/2014/main" id="{35FBFE6C-3A61-49E1-A62D-3E96B5D28C24}"/>
+                <a16:creationId xmlns:a16="http://schemas.microsoft.com/office/drawing/2014/main" id="{8CFCEC7A-5777-4E84-8AE1-C41DE98C5F22}"/>
               </a:ext>
             </a:extLst>
           </p:cNvPr>
@@ -2074,7 +2074,7 @@
           <p:cNvPr id="2" name="">
             <a:extLst xmlns:a="http://schemas.openxmlformats.org/drawingml/2006/main">
               <a:ext uri="{FF2B5EF4-FFF2-40B4-BE49-F238E27FC236}">
-                <a16:creationId xmlns:a16="http://schemas.microsoft.com/office/drawing/2014/main" id="{0C962861-6151-4BC9-8FA3-16B169A19DDB}"/>
+                <a16:creationId xmlns:a16="http://schemas.microsoft.com/office/drawing/2014/main" id="{F283C861-C6A4-43BB-A7A6-29FD57DBDB73}"/>
               </a:ext>
             </a:extLst>
           </p:cNvPr>
@@ -2086,7 +2086,7 @@
         <p:spPr>
           <a:xfrm xmlns:a="http://schemas.openxmlformats.org/drawingml/2006/main">
             <a:off x="647700" y="361950"/>
-            <a:ext cx="4000500" cy="266700"/>
+            <a:ext cx="4953000" cy="266700"/>
           </a:xfrm>
           <a:prstGeom xmlns:a="http://schemas.openxmlformats.org/drawingml/2006/main" prst="rect">
             <a:avLst/>
@@ -2109,7 +2109,7 @@
               </a:defRPr>
             </a:pPr>
             <a:r>
-              <a:t>NORTH STAR</a:t>
+              <a:t>SRIB NORTH STAR</a:t>
             </a:r>
           </a:p>
         </p:txBody>
@@ -2119,7 +2119,7 @@
           <p:cNvPr id="3" name="">
             <a:extLst xmlns:a="http://schemas.openxmlformats.org/drawingml/2006/main">
               <a:ext uri="{FF2B5EF4-FFF2-40B4-BE49-F238E27FC236}">
-                <a16:creationId xmlns:a16="http://schemas.microsoft.com/office/drawing/2014/main" id="{DDA95FBE-B682-4AA0-B4AC-17E306813AB9}"/>
+                <a16:creationId xmlns:a16="http://schemas.microsoft.com/office/drawing/2014/main" id="{A1655A50-AAA6-4AFF-BAC6-3BA441BE6043}"/>
               </a:ext>
             </a:extLst>
           </p:cNvPr>
@@ -2164,7 +2164,7 @@
           <p:cNvPr id="4" name="">
             <a:extLst xmlns:a="http://schemas.openxmlformats.org/drawingml/2006/main">
               <a:ext uri="{FF2B5EF4-FFF2-40B4-BE49-F238E27FC236}">
-                <a16:creationId xmlns:a16="http://schemas.microsoft.com/office/drawing/2014/main" id="{412E6080-15D9-4F8A-ABB6-615F1BE98D70}"/>
+                <a16:creationId xmlns:a16="http://schemas.microsoft.com/office/drawing/2014/main" id="{E65B9469-8E07-4554-9967-AB8E89922E47}"/>
               </a:ext>
             </a:extLst>
           </p:cNvPr>
@@ -2176,7 +2176,7 @@
         <p:spPr>
           <a:xfrm xmlns:a="http://schemas.openxmlformats.org/drawingml/2006/main">
             <a:off x="457200" y="800100"/>
-            <a:ext cx="7905750" cy="876300"/>
+            <a:ext cx="8096250" cy="876300"/>
           </a:xfrm>
           <a:prstGeom xmlns:a="http://schemas.openxmlformats.org/drawingml/2006/main" prst="rect">
             <a:avLst/>
@@ -2199,7 +2199,7 @@
               </a:defRPr>
             </a:pPr>
             <a:r>
-              <a:t>Move leadership from episodic review to everyday practice.</a:t>
+              <a:t>Make people leadership an everyday SRIB practice.</a:t>
             </a:r>
           </a:p>
         </p:txBody>
@@ -2209,7 +2209,7 @@
           <p:cNvPr id="5" name="">
             <a:extLst xmlns:a="http://schemas.openxmlformats.org/drawingml/2006/main">
               <a:ext uri="{FF2B5EF4-FFF2-40B4-BE49-F238E27FC236}">
-                <a16:creationId xmlns:a16="http://schemas.microsoft.com/office/drawing/2014/main" id="{4210D6FE-B86F-4F1E-9957-4A27CAA1AA74}"/>
+                <a16:creationId xmlns:a16="http://schemas.microsoft.com/office/drawing/2014/main" id="{E77A7FE6-C6DE-4A86-BC90-769F873DE767}"/>
               </a:ext>
             </a:extLst>
           </p:cNvPr>
@@ -2221,7 +2221,7 @@
         <p:spPr>
           <a:xfrm xmlns:a="http://schemas.openxmlformats.org/drawingml/2006/main">
             <a:off x="476250" y="1752600"/>
-            <a:ext cx="7239000" cy="533400"/>
+            <a:ext cx="7667625" cy="552450"/>
           </a:xfrm>
           <a:prstGeom xmlns:a="http://schemas.openxmlformats.org/drawingml/2006/main" prst="rect">
             <a:avLst/>
@@ -2244,7 +2244,7 @@
               </a:defRPr>
             </a:pPr>
             <a:r>
-              <a:t>The program should make the expected manager behavior visible, repeatable, measurable, and supported by tools.</a:t>
+              <a:t>By December 2026, employees should experience clearer expectations, faster feedback, stronger coaching, and better support from their managers.</a:t>
             </a:r>
           </a:p>
         </p:txBody>
@@ -2254,7 +2254,7 @@
           <p:cNvPr id="6" name="">
             <a:extLst xmlns:a="http://schemas.openxmlformats.org/drawingml/2006/main">
               <a:ext uri="{FF2B5EF4-FFF2-40B4-BE49-F238E27FC236}">
-                <a16:creationId xmlns:a16="http://schemas.microsoft.com/office/drawing/2014/main" id="{0137FF45-C75B-473F-B80A-D0A445576981}"/>
+                <a16:creationId xmlns:a16="http://schemas.microsoft.com/office/drawing/2014/main" id="{5EA40199-FA21-4E59-85F4-0A374F1B0F58}"/>
               </a:ext>
             </a:extLst>
           </p:cNvPr>
@@ -2283,7 +2283,7 @@
           <p:cNvPr id="7" name="">
             <a:extLst xmlns:a="http://schemas.openxmlformats.org/drawingml/2006/main">
               <a:ext uri="{FF2B5EF4-FFF2-40B4-BE49-F238E27FC236}">
-                <a16:creationId xmlns:a16="http://schemas.microsoft.com/office/drawing/2014/main" id="{4AD3DF77-D088-4F6F-B5BC-8B1B69C4200A}"/>
+                <a16:creationId xmlns:a16="http://schemas.microsoft.com/office/drawing/2014/main" id="{D3123908-A95A-4395-98EA-760BE8EC3E10}"/>
               </a:ext>
             </a:extLst>
           </p:cNvPr>
@@ -2328,7 +2328,7 @@
           <p:cNvPr id="8" name="">
             <a:extLst xmlns:a="http://schemas.openxmlformats.org/drawingml/2006/main">
               <a:ext uri="{FF2B5EF4-FFF2-40B4-BE49-F238E27FC236}">
-                <a16:creationId xmlns:a16="http://schemas.microsoft.com/office/drawing/2014/main" id="{7DA44281-FF54-480F-8316-D8F6AB80597F}"/>
+                <a16:creationId xmlns:a16="http://schemas.microsoft.com/office/drawing/2014/main" id="{0032A205-7D05-4440-941C-E5CECE6456FF}"/>
               </a:ext>
             </a:extLst>
           </p:cNvPr>
@@ -2357,7 +2357,7 @@
           <p:cNvPr id="9" name="">
             <a:extLst xmlns:a="http://schemas.openxmlformats.org/drawingml/2006/main">
               <a:ext uri="{FF2B5EF4-FFF2-40B4-BE49-F238E27FC236}">
-                <a16:creationId xmlns:a16="http://schemas.microsoft.com/office/drawing/2014/main" id="{DBF2C05E-1147-438C-BBC5-FD209B86258C}"/>
+                <a16:creationId xmlns:a16="http://schemas.microsoft.com/office/drawing/2014/main" id="{6C8BC50B-FBFE-4560-B69A-29993A72257A}"/>
               </a:ext>
             </a:extLst>
           </p:cNvPr>
@@ -2402,7 +2402,7 @@
           <p:cNvPr id="10" name="">
             <a:extLst xmlns:a="http://schemas.openxmlformats.org/drawingml/2006/main">
               <a:ext uri="{FF2B5EF4-FFF2-40B4-BE49-F238E27FC236}">
-                <a16:creationId xmlns:a16="http://schemas.microsoft.com/office/drawing/2014/main" id="{D6B1CE9D-F10F-41D5-8077-D7F2FD1E27C7}"/>
+                <a16:creationId xmlns:a16="http://schemas.microsoft.com/office/drawing/2014/main" id="{A7F34C94-0492-42DE-9863-30EB6472A53A}"/>
               </a:ext>
             </a:extLst>
           </p:cNvPr>
@@ -2447,7 +2447,7 @@
           <p:cNvPr id="11" name="">
             <a:extLst xmlns:a="http://schemas.openxmlformats.org/drawingml/2006/main">
               <a:ext uri="{FF2B5EF4-FFF2-40B4-BE49-F238E27FC236}">
-                <a16:creationId xmlns:a16="http://schemas.microsoft.com/office/drawing/2014/main" id="{587F086D-B4A2-4D20-93A6-FA2F7576F0EC}"/>
+                <a16:creationId xmlns:a16="http://schemas.microsoft.com/office/drawing/2014/main" id="{B768E0C7-E3ED-4F3F-9B17-AEB1255EB250}"/>
               </a:ext>
             </a:extLst>
           </p:cNvPr>
@@ -2476,7 +2476,7 @@
           <p:cNvPr id="12" name="">
             <a:extLst xmlns:a="http://schemas.openxmlformats.org/drawingml/2006/main">
               <a:ext uri="{FF2B5EF4-FFF2-40B4-BE49-F238E27FC236}">
-                <a16:creationId xmlns:a16="http://schemas.microsoft.com/office/drawing/2014/main" id="{70AFAF9D-62E3-483A-996C-8582FEEA19B5}"/>
+                <a16:creationId xmlns:a16="http://schemas.microsoft.com/office/drawing/2014/main" id="{6BECAB73-BE68-4C8F-B7FE-0CACA21024C2}"/>
               </a:ext>
             </a:extLst>
           </p:cNvPr>
@@ -2505,7 +2505,7 @@
           <p:cNvPr id="13" name="">
             <a:extLst xmlns:a="http://schemas.openxmlformats.org/drawingml/2006/main">
               <a:ext uri="{FF2B5EF4-FFF2-40B4-BE49-F238E27FC236}">
-                <a16:creationId xmlns:a16="http://schemas.microsoft.com/office/drawing/2014/main" id="{63D5FDFE-FA4D-4866-81F3-F102508FAC2B}"/>
+                <a16:creationId xmlns:a16="http://schemas.microsoft.com/office/drawing/2014/main" id="{F18268D5-7F88-4F25-BAC7-748E1A1B0E5E}"/>
               </a:ext>
             </a:extLst>
           </p:cNvPr>
@@ -2550,7 +2550,7 @@
           <p:cNvPr id="14" name="">
             <a:extLst xmlns:a="http://schemas.openxmlformats.org/drawingml/2006/main">
               <a:ext uri="{FF2B5EF4-FFF2-40B4-BE49-F238E27FC236}">
-                <a16:creationId xmlns:a16="http://schemas.microsoft.com/office/drawing/2014/main" id="{56DAE9A7-C343-4F03-83D1-FB24247EBDAB}"/>
+                <a16:creationId xmlns:a16="http://schemas.microsoft.com/office/drawing/2014/main" id="{400BBD61-6A25-45EB-BC62-6E3AA390D593}"/>
               </a:ext>
             </a:extLst>
           </p:cNvPr>
@@ -2595,7 +2595,7 @@
           <p:cNvPr id="15" name="">
             <a:extLst xmlns:a="http://schemas.openxmlformats.org/drawingml/2006/main">
               <a:ext uri="{FF2B5EF4-FFF2-40B4-BE49-F238E27FC236}">
-                <a16:creationId xmlns:a16="http://schemas.microsoft.com/office/drawing/2014/main" id="{EE33D835-571D-4866-A326-5284585C99DF}"/>
+                <a16:creationId xmlns:a16="http://schemas.microsoft.com/office/drawing/2014/main" id="{3AD7022A-7258-46D0-9CB9-C7E9BFAF5F9B}"/>
               </a:ext>
             </a:extLst>
           </p:cNvPr>
@@ -2624,7 +2624,7 @@
           <p:cNvPr id="16" name="">
             <a:extLst xmlns:a="http://schemas.openxmlformats.org/drawingml/2006/main">
               <a:ext uri="{FF2B5EF4-FFF2-40B4-BE49-F238E27FC236}">
-                <a16:creationId xmlns:a16="http://schemas.microsoft.com/office/drawing/2014/main" id="{7C72F6FB-C1B6-4DA7-B8E9-0A2444391C2A}"/>
+                <a16:creationId xmlns:a16="http://schemas.microsoft.com/office/drawing/2014/main" id="{8C270F51-0160-4ED6-B6D0-33C78ED0BC42}"/>
               </a:ext>
             </a:extLst>
           </p:cNvPr>
@@ -2653,7 +2653,7 @@
           <p:cNvPr id="17" name="">
             <a:extLst xmlns:a="http://schemas.openxmlformats.org/drawingml/2006/main">
               <a:ext uri="{FF2B5EF4-FFF2-40B4-BE49-F238E27FC236}">
-                <a16:creationId xmlns:a16="http://schemas.microsoft.com/office/drawing/2014/main" id="{3AD98485-2231-424C-99D4-023A30D66AC3}"/>
+                <a16:creationId xmlns:a16="http://schemas.microsoft.com/office/drawing/2014/main" id="{3627DCFB-C5D7-4147-AC79-8B5C7C20B950}"/>
               </a:ext>
             </a:extLst>
           </p:cNvPr>
@@ -2698,7 +2698,7 @@
           <p:cNvPr id="18" name="">
             <a:extLst xmlns:a="http://schemas.openxmlformats.org/drawingml/2006/main">
               <a:ext uri="{FF2B5EF4-FFF2-40B4-BE49-F238E27FC236}">
-                <a16:creationId xmlns:a16="http://schemas.microsoft.com/office/drawing/2014/main" id="{00DF1A80-A3FB-4A4E-804D-95DE12BBA9DD}"/>
+                <a16:creationId xmlns:a16="http://schemas.microsoft.com/office/drawing/2014/main" id="{2D5A25FE-FE3D-4014-8E20-BA07366920E5}"/>
               </a:ext>
             </a:extLst>
           </p:cNvPr>
@@ -2718,7 +2718,7 @@
         </p:spPr>
         <p:txBody>
           <a:bodyPr xmlns:a="http://schemas.openxmlformats.org/drawingml/2006/main" lIns="0" tIns="0" rIns="0" bIns="0">
-            <a:normAutofit fontScale="91650"/>
+            <a:normAutofit fontScale="100000"/>
           </a:bodyPr>
           <a:lstStyle xmlns:a="http://schemas.openxmlformats.org/drawingml/2006/main"/>
           <a:p xmlns:a="http://schemas.openxmlformats.org/drawingml/2006/main">
@@ -2733,7 +2733,7 @@
               </a:defRPr>
             </a:pPr>
             <a:r>
-              <a:t>Weekly growth signals</a:t>
+              <a:t>Continuous signals</a:t>
             </a:r>
           </a:p>
         </p:txBody>
@@ -2743,7 +2743,7 @@
           <p:cNvPr id="19" name="">
             <a:extLst xmlns:a="http://schemas.openxmlformats.org/drawingml/2006/main">
               <a:ext uri="{FF2B5EF4-FFF2-40B4-BE49-F238E27FC236}">
-                <a16:creationId xmlns:a16="http://schemas.microsoft.com/office/drawing/2014/main" id="{284ABB97-CA86-4B12-9B76-68B883946B60}"/>
+                <a16:creationId xmlns:a16="http://schemas.microsoft.com/office/drawing/2014/main" id="{786EFC30-5127-4FC9-B0DE-5D656C610FCF}"/>
               </a:ext>
             </a:extLst>
           </p:cNvPr>
@@ -2772,7 +2772,7 @@
           <p:cNvPr id="20" name="">
             <a:extLst xmlns:a="http://schemas.openxmlformats.org/drawingml/2006/main">
               <a:ext uri="{FF2B5EF4-FFF2-40B4-BE49-F238E27FC236}">
-                <a16:creationId xmlns:a16="http://schemas.microsoft.com/office/drawing/2014/main" id="{ACDE91E0-542D-456D-9900-9607C8202F56}"/>
+                <a16:creationId xmlns:a16="http://schemas.microsoft.com/office/drawing/2014/main" id="{A37090BC-9751-45A5-ADA5-E85CA235C016}"/>
               </a:ext>
             </a:extLst>
           </p:cNvPr>
@@ -2801,7 +2801,7 @@
           <p:cNvPr id="21" name="">
             <a:extLst xmlns:a="http://schemas.openxmlformats.org/drawingml/2006/main">
               <a:ext uri="{FF2B5EF4-FFF2-40B4-BE49-F238E27FC236}">
-                <a16:creationId xmlns:a16="http://schemas.microsoft.com/office/drawing/2014/main" id="{7EC73C57-7B66-4B22-96F1-1EB35D95C8DA}"/>
+                <a16:creationId xmlns:a16="http://schemas.microsoft.com/office/drawing/2014/main" id="{7CEC9F7D-1C8D-4478-9937-E2C42F944875}"/>
               </a:ext>
             </a:extLst>
           </p:cNvPr>
@@ -2846,7 +2846,7 @@
           <p:cNvPr id="22" name="">
             <a:extLst xmlns:a="http://schemas.openxmlformats.org/drawingml/2006/main">
               <a:ext uri="{FF2B5EF4-FFF2-40B4-BE49-F238E27FC236}">
-                <a16:creationId xmlns:a16="http://schemas.microsoft.com/office/drawing/2014/main" id="{62022417-5EA4-46BA-B5C3-7E257813AB28}"/>
+                <a16:creationId xmlns:a16="http://schemas.microsoft.com/office/drawing/2014/main" id="{BD2F8F48-786E-40D8-92FE-679940B9C7B4}"/>
               </a:ext>
             </a:extLst>
           </p:cNvPr>
@@ -2891,7 +2891,7 @@
           <p:cNvPr id="23" name="">
             <a:extLst xmlns:a="http://schemas.openxmlformats.org/drawingml/2006/main">
               <a:ext uri="{FF2B5EF4-FFF2-40B4-BE49-F238E27FC236}">
-                <a16:creationId xmlns:a16="http://schemas.microsoft.com/office/drawing/2014/main" id="{D2EF14DD-BEA3-48ED-922F-0F4BE4ACE349}"/>
+                <a16:creationId xmlns:a16="http://schemas.microsoft.com/office/drawing/2014/main" id="{4773A7D9-47C3-42B8-97B2-8F7D54544813}"/>
               </a:ext>
             </a:extLst>
           </p:cNvPr>
@@ -2920,7 +2920,7 @@
           <p:cNvPr id="24" name="">
             <a:extLst xmlns:a="http://schemas.openxmlformats.org/drawingml/2006/main">
               <a:ext uri="{FF2B5EF4-FFF2-40B4-BE49-F238E27FC236}">
-                <a16:creationId xmlns:a16="http://schemas.microsoft.com/office/drawing/2014/main" id="{FA64CA1B-8BD6-45C8-9D39-78AB21ADCB94}"/>
+                <a16:creationId xmlns:a16="http://schemas.microsoft.com/office/drawing/2014/main" id="{2ABB910D-180E-4BFE-8A4E-8D79E6AE4549}"/>
               </a:ext>
             </a:extLst>
           </p:cNvPr>
@@ -2949,7 +2949,7 @@
           <p:cNvPr id="25" name="">
             <a:extLst xmlns:a="http://schemas.openxmlformats.org/drawingml/2006/main">
               <a:ext uri="{FF2B5EF4-FFF2-40B4-BE49-F238E27FC236}">
-                <a16:creationId xmlns:a16="http://schemas.microsoft.com/office/drawing/2014/main" id="{B99D52F6-7B6F-4538-9DA6-46409A6C1DB1}"/>
+                <a16:creationId xmlns:a16="http://schemas.microsoft.com/office/drawing/2014/main" id="{37EE7CA8-F52C-4E3C-8701-BF23F79E7C6C}"/>
               </a:ext>
             </a:extLst>
           </p:cNvPr>
@@ -2994,7 +2994,7 @@
           <p:cNvPr id="26" name="">
             <a:extLst xmlns:a="http://schemas.openxmlformats.org/drawingml/2006/main">
               <a:ext uri="{FF2B5EF4-FFF2-40B4-BE49-F238E27FC236}">
-                <a16:creationId xmlns:a16="http://schemas.microsoft.com/office/drawing/2014/main" id="{B638E15B-8A88-4A29-B269-918A38F62A9C}"/>
+                <a16:creationId xmlns:a16="http://schemas.microsoft.com/office/drawing/2014/main" id="{6085F376-0156-4EFD-AFA2-AC5853F476C9}"/>
               </a:ext>
             </a:extLst>
           </p:cNvPr>
@@ -3014,7 +3014,7 @@
         </p:spPr>
         <p:txBody>
           <a:bodyPr xmlns:a="http://schemas.openxmlformats.org/drawingml/2006/main" lIns="0" tIns="0" rIns="0" bIns="0">
-            <a:normAutofit fontScale="80806"/>
+            <a:normAutofit fontScale="100000"/>
           </a:bodyPr>
           <a:lstStyle xmlns:a="http://schemas.openxmlformats.org/drawingml/2006/main"/>
           <a:p xmlns:a="http://schemas.openxmlformats.org/drawingml/2006/main">
@@ -3029,7 +3029,7 @@
               </a:defRPr>
             </a:pPr>
             <a:r>
-              <a:t>Circles and walkthroughs</a:t>
+              <a:t>Leader circles</a:t>
             </a:r>
           </a:p>
         </p:txBody>
@@ -3039,7 +3039,7 @@
           <p:cNvPr id="27" name="">
             <a:extLst xmlns:a="http://schemas.openxmlformats.org/drawingml/2006/main">
               <a:ext uri="{FF2B5EF4-FFF2-40B4-BE49-F238E27FC236}">
-                <a16:creationId xmlns:a16="http://schemas.microsoft.com/office/drawing/2014/main" id="{858A440B-1E21-4CF3-AC19-FEACB9EB39F8}"/>
+                <a16:creationId xmlns:a16="http://schemas.microsoft.com/office/drawing/2014/main" id="{3229EE49-E2E0-4982-A508-1DF7A3F92501}"/>
               </a:ext>
             </a:extLst>
           </p:cNvPr>
@@ -3068,7 +3068,7 @@
           <p:cNvPr id="28" name="">
             <a:extLst xmlns:a="http://schemas.openxmlformats.org/drawingml/2006/main">
               <a:ext uri="{FF2B5EF4-FFF2-40B4-BE49-F238E27FC236}">
-                <a16:creationId xmlns:a16="http://schemas.microsoft.com/office/drawing/2014/main" id="{3E384FBE-6511-4E35-87E6-E900226DD722}"/>
+                <a16:creationId xmlns:a16="http://schemas.microsoft.com/office/drawing/2014/main" id="{8CA23643-4258-4B17-98E7-49EFA6571F9C}"/>
               </a:ext>
             </a:extLst>
           </p:cNvPr>
@@ -3097,7 +3097,7 @@
           <p:cNvPr id="29" name="">
             <a:extLst xmlns:a="http://schemas.openxmlformats.org/drawingml/2006/main">
               <a:ext uri="{FF2B5EF4-FFF2-40B4-BE49-F238E27FC236}">
-                <a16:creationId xmlns:a16="http://schemas.microsoft.com/office/drawing/2014/main" id="{3FE08FCB-630F-43C7-B523-CA7DCC64B7D8}"/>
+                <a16:creationId xmlns:a16="http://schemas.microsoft.com/office/drawing/2014/main" id="{00AFE964-97C5-4FDD-8CA8-95B88256C644}"/>
               </a:ext>
             </a:extLst>
           </p:cNvPr>
@@ -3132,7 +3132,7 @@
               </a:defRPr>
             </a:pPr>
             <a:r>
-              <a:t>Everyday leadership standard</a:t>
+              <a:t>For managers</a:t>
             </a:r>
           </a:p>
         </p:txBody>
@@ -3142,7 +3142,7 @@
           <p:cNvPr id="30" name="">
             <a:extLst xmlns:a="http://schemas.openxmlformats.org/drawingml/2006/main">
               <a:ext uri="{FF2B5EF4-FFF2-40B4-BE49-F238E27FC236}">
-                <a16:creationId xmlns:a16="http://schemas.microsoft.com/office/drawing/2014/main" id="{40F9C5F8-14EF-4EC7-8035-63E902CF2338}"/>
+                <a16:creationId xmlns:a16="http://schemas.microsoft.com/office/drawing/2014/main" id="{90DEE43C-92D8-4196-BD9E-22A33CB96F0E}"/>
               </a:ext>
             </a:extLst>
           </p:cNvPr>
@@ -3177,7 +3177,7 @@
               </a:defRPr>
             </a:pPr>
             <a:r>
-              <a:t>Define three non-negotiable behaviors: coaching questions in 1:1s, timely feedback after work moments, and visible support for learning.</a:t>
+              <a:t>A common SRIB standard for 1:1s, coaching conversations, feedback moments, and team learning routines.</a:t>
             </a:r>
           </a:p>
         </p:txBody>
@@ -3187,7 +3187,7 @@
           <p:cNvPr id="31" name="">
             <a:extLst xmlns:a="http://schemas.openxmlformats.org/drawingml/2006/main">
               <a:ext uri="{FF2B5EF4-FFF2-40B4-BE49-F238E27FC236}">
-                <a16:creationId xmlns:a16="http://schemas.microsoft.com/office/drawing/2014/main" id="{D67F05CC-299D-479B-B7B6-E56536F69D10}"/>
+                <a16:creationId xmlns:a16="http://schemas.microsoft.com/office/drawing/2014/main" id="{C81A122B-6BFB-47B7-9BAE-962EFA562F2F}"/>
               </a:ext>
             </a:extLst>
           </p:cNvPr>
@@ -3216,7 +3216,7 @@
           <p:cNvPr id="32" name="">
             <a:extLst xmlns:a="http://schemas.openxmlformats.org/drawingml/2006/main">
               <a:ext uri="{FF2B5EF4-FFF2-40B4-BE49-F238E27FC236}">
-                <a16:creationId xmlns:a16="http://schemas.microsoft.com/office/drawing/2014/main" id="{9703CED4-7865-4185-93DE-8B2D3088C371}"/>
+                <a16:creationId xmlns:a16="http://schemas.microsoft.com/office/drawing/2014/main" id="{2958F93F-0731-4709-94B2-7D3E4D54B243}"/>
               </a:ext>
             </a:extLst>
           </p:cNvPr>
@@ -3245,7 +3245,7 @@
           <p:cNvPr id="33" name="">
             <a:extLst xmlns:a="http://schemas.openxmlformats.org/drawingml/2006/main">
               <a:ext uri="{FF2B5EF4-FFF2-40B4-BE49-F238E27FC236}">
-                <a16:creationId xmlns:a16="http://schemas.microsoft.com/office/drawing/2014/main" id="{AA641BB1-97D8-429B-AC88-90B63F1AADEB}"/>
+                <a16:creationId xmlns:a16="http://schemas.microsoft.com/office/drawing/2014/main" id="{C7BDF5A0-DC14-448B-A9A6-8422C5553ED1}"/>
               </a:ext>
             </a:extLst>
           </p:cNvPr>
@@ -3280,7 +3280,7 @@
               </a:defRPr>
             </a:pPr>
             <a:r>
-              <a:t>Employee experience promise</a:t>
+              <a:t>For employees</a:t>
             </a:r>
           </a:p>
         </p:txBody>
@@ -3290,7 +3290,7 @@
           <p:cNvPr id="34" name="">
             <a:extLst xmlns:a="http://schemas.openxmlformats.org/drawingml/2006/main">
               <a:ext uri="{FF2B5EF4-FFF2-40B4-BE49-F238E27FC236}">
-                <a16:creationId xmlns:a16="http://schemas.microsoft.com/office/drawing/2014/main" id="{32F32382-DB52-43EF-9AC7-A90D70F75211}"/>
+                <a16:creationId xmlns:a16="http://schemas.microsoft.com/office/drawing/2014/main" id="{2D8318C6-0589-445D-8E4B-0C1961DB79AF}"/>
               </a:ext>
             </a:extLst>
           </p:cNvPr>
@@ -3325,7 +3325,7 @@
               </a:defRPr>
             </a:pPr>
             <a:r>
-              <a:t>Employees receive useful guidance before the annual cycle: expectations, feedback, recognition, and help unblocking work.</a:t>
+              <a:t>More timely guidance, stronger recognition, clearer growth conversations, and fewer surprises in formal review cycles.</a:t>
             </a:r>
           </a:p>
         </p:txBody>
@@ -3335,7 +3335,7 @@
           <p:cNvPr id="35" name="">
             <a:extLst xmlns:a="http://schemas.openxmlformats.org/drawingml/2006/main">
               <a:ext uri="{FF2B5EF4-FFF2-40B4-BE49-F238E27FC236}">
-                <a16:creationId xmlns:a16="http://schemas.microsoft.com/office/drawing/2014/main" id="{E5DAF383-6368-4E99-BB80-B748F891CB3E}"/>
+                <a16:creationId xmlns:a16="http://schemas.microsoft.com/office/drawing/2014/main" id="{E33D8A32-9349-4D56-922E-97E2B407638B}"/>
               </a:ext>
             </a:extLst>
           </p:cNvPr>
@@ -3364,7 +3364,7 @@
           <p:cNvPr id="36" name="">
             <a:extLst xmlns:a="http://schemas.openxmlformats.org/drawingml/2006/main">
               <a:ext uri="{FF2B5EF4-FFF2-40B4-BE49-F238E27FC236}">
-                <a16:creationId xmlns:a16="http://schemas.microsoft.com/office/drawing/2014/main" id="{EF82B101-804B-41A9-AD62-A870CF862185}"/>
+                <a16:creationId xmlns:a16="http://schemas.microsoft.com/office/drawing/2014/main" id="{3D106731-5BC9-416B-BCEC-F1136DA09A81}"/>
               </a:ext>
             </a:extLst>
           </p:cNvPr>
@@ -3393,7 +3393,7 @@
           <p:cNvPr id="37" name="">
             <a:extLst xmlns:a="http://schemas.openxmlformats.org/drawingml/2006/main">
               <a:ext uri="{FF2B5EF4-FFF2-40B4-BE49-F238E27FC236}">
-                <a16:creationId xmlns:a16="http://schemas.microsoft.com/office/drawing/2014/main" id="{F2CF990A-9B05-40ED-ABE2-D651F609EC7D}"/>
+                <a16:creationId xmlns:a16="http://schemas.microsoft.com/office/drawing/2014/main" id="{9F082410-5691-408B-AA21-81CB758A0206}"/>
               </a:ext>
             </a:extLst>
           </p:cNvPr>
@@ -3428,7 +3428,7 @@
               </a:defRPr>
             </a:pPr>
             <a:r>
-              <a:t>Leadership accountability</a:t>
+              <a:t>For leaders</a:t>
             </a:r>
           </a:p>
         </p:txBody>
@@ -3438,7 +3438,7 @@
           <p:cNvPr id="38" name="">
             <a:extLst xmlns:a="http://schemas.openxmlformats.org/drawingml/2006/main">
               <a:ext uri="{FF2B5EF4-FFF2-40B4-BE49-F238E27FC236}">
-                <a16:creationId xmlns:a16="http://schemas.microsoft.com/office/drawing/2014/main" id="{401C4819-42B8-4894-9479-879AABA3B7CC}"/>
+                <a16:creationId xmlns:a16="http://schemas.microsoft.com/office/drawing/2014/main" id="{9DD735B7-62EA-483F-9653-C8645B32E1F5}"/>
               </a:ext>
             </a:extLst>
           </p:cNvPr>
@@ -3473,7 +3473,7 @@
               </a:defRPr>
             </a:pPr>
             <a:r>
-              <a:t>Leaders model the same habits through learning circles, walk-and-talks, skip-level listening, and quarterly pulse reviews.</a:t>
+              <a:t>Visible modeling through learning circles, walk-and-talks, skip-level listening, and monthly adoption reviews.</a:t>
             </a:r>
           </a:p>
         </p:txBody>
@@ -3483,7 +3483,7 @@
           <p:cNvPr id="39" name="">
             <a:extLst xmlns:a="http://schemas.openxmlformats.org/drawingml/2006/main">
               <a:ext uri="{FF2B5EF4-FFF2-40B4-BE49-F238E27FC236}">
-                <a16:creationId xmlns:a16="http://schemas.microsoft.com/office/drawing/2014/main" id="{B6E55246-4F98-4555-BA84-BF10D9E77743}"/>
+                <a16:creationId xmlns:a16="http://schemas.microsoft.com/office/drawing/2014/main" id="{63E4F5D8-7A3E-4673-953C-EE7AB34D2752}"/>
               </a:ext>
             </a:extLst>
           </p:cNvPr>
@@ -3518,7 +3518,7 @@
               </a:defRPr>
             </a:pPr>
             <a:r>
-              <a:t>Outcome: a common operating system for how managers grow people while delivering business results.</a:t>
+              <a:t>Outcome: SRIB managers grow people continuously while sustaining delivery excellence.</a:t>
             </a:r>
           </a:p>
         </p:txBody>
@@ -3528,7 +3528,7 @@
           <p:cNvPr id="40" name="">
             <a:extLst xmlns:a="http://schemas.openxmlformats.org/drawingml/2006/main">
               <a:ext uri="{FF2B5EF4-FFF2-40B4-BE49-F238E27FC236}">
-                <a16:creationId xmlns:a16="http://schemas.microsoft.com/office/drawing/2014/main" id="{4CB6FCF9-092A-4176-AC72-B5B35B13D298}"/>
+                <a16:creationId xmlns:a16="http://schemas.microsoft.com/office/drawing/2014/main" id="{46D39A93-2FDA-46E7-98E5-BFC9380C541D}"/>
               </a:ext>
             </a:extLst>
           </p:cNvPr>
@@ -3540,7 +3540,7 @@
         <p:spPr>
           <a:xfrm xmlns:a="http://schemas.openxmlformats.org/drawingml/2006/main">
             <a:off x="457200" y="6438900"/>
-            <a:ext cx="6858000" cy="171450"/>
+            <a:ext cx="7239000" cy="171450"/>
           </a:xfrm>
           <a:prstGeom xmlns:a="http://schemas.openxmlformats.org/drawingml/2006/main" prst="rect">
             <a:avLst/>
@@ -3563,7 +3563,7 @@
               </a:defRPr>
             </a:pPr>
             <a:r>
-              <a:t>Leadership Task Force | Manager Effectiveness and Everyday Leadership | Samsung India</a:t>
+              <a:t>Samsung R&amp;D Institute Bangalore | SRIB Managers and Employees | June-Dec 2026</a:t>
             </a:r>
           </a:p>
         </p:txBody>
@@ -3571,7 +3571,7 @@
     </p:spTree>
     <p:extLst>
       <p:ext uri="{BB962C8B-B14F-4D97-AF65-F5344CB8AC3E}">
-        <p14:creationId xmlns:p14="http://schemas.microsoft.com/office/powerpoint/2010/main" val="1668351160"/>
+        <p14:creationId xmlns:p14="http://schemas.microsoft.com/office/powerpoint/2010/main" val="1631761809"/>
       </p:ext>
     </p:extLst>
   </p:cSld>
@@ -3602,7 +3602,7 @@
           <p:cNvPr id="1" name="">
             <a:extLst xmlns:a="http://schemas.openxmlformats.org/drawingml/2006/main">
               <a:ext uri="{FF2B5EF4-FFF2-40B4-BE49-F238E27FC236}">
-                <a16:creationId xmlns:a16="http://schemas.microsoft.com/office/drawing/2014/main" id="{389F0DD6-86B1-4345-B511-6C2F678981F0}"/>
+                <a16:creationId xmlns:a16="http://schemas.microsoft.com/office/drawing/2014/main" id="{4F1F7B08-8A3C-4679-97F5-1DBE3FC0DE6D}"/>
               </a:ext>
             </a:extLst>
           </p:cNvPr>
@@ -3631,7 +3631,7 @@
           <p:cNvPr id="2" name="">
             <a:extLst xmlns:a="http://schemas.openxmlformats.org/drawingml/2006/main">
               <a:ext uri="{FF2B5EF4-FFF2-40B4-BE49-F238E27FC236}">
-                <a16:creationId xmlns:a16="http://schemas.microsoft.com/office/drawing/2014/main" id="{CD43D592-21E2-4C86-B91A-E6C088C03D69}"/>
+                <a16:creationId xmlns:a16="http://schemas.microsoft.com/office/drawing/2014/main" id="{A42E13FC-3E9C-4D34-A3F8-CFF23C7FEB8E}"/>
               </a:ext>
             </a:extLst>
           </p:cNvPr>
@@ -3643,7 +3643,7 @@
         <p:spPr>
           <a:xfrm xmlns:a="http://schemas.openxmlformats.org/drawingml/2006/main">
             <a:off x="647700" y="361950"/>
-            <a:ext cx="4000500" cy="266700"/>
+            <a:ext cx="4953000" cy="266700"/>
           </a:xfrm>
           <a:prstGeom xmlns:a="http://schemas.openxmlformats.org/drawingml/2006/main" prst="rect">
             <a:avLst/>
@@ -3666,7 +3666,7 @@
               </a:defRPr>
             </a:pPr>
             <a:r>
-              <a:t>INITIATIVE ARCHITECTURE</a:t>
+              <a:t>JUNE-DEC 2026 WORKSTREAMS</a:t>
             </a:r>
           </a:p>
         </p:txBody>
@@ -3676,7 +3676,7 @@
           <p:cNvPr id="3" name="">
             <a:extLst xmlns:a="http://schemas.openxmlformats.org/drawingml/2006/main">
               <a:ext uri="{FF2B5EF4-FFF2-40B4-BE49-F238E27FC236}">
-                <a16:creationId xmlns:a16="http://schemas.microsoft.com/office/drawing/2014/main" id="{0AAA8E51-1EAE-47F6-A7C7-634052C28DDB}"/>
+                <a16:creationId xmlns:a16="http://schemas.microsoft.com/office/drawing/2014/main" id="{AF9D4F3B-6373-4778-ABCE-6CD1C9B7CB44}"/>
               </a:ext>
             </a:extLst>
           </p:cNvPr>
@@ -3721,7 +3721,7 @@
           <p:cNvPr id="4" name="">
             <a:extLst xmlns:a="http://schemas.openxmlformats.org/drawingml/2006/main">
               <a:ext uri="{FF2B5EF4-FFF2-40B4-BE49-F238E27FC236}">
-                <a16:creationId xmlns:a16="http://schemas.microsoft.com/office/drawing/2014/main" id="{2C265FDC-AB88-459F-B0DA-9CD5162F27DD}"/>
+                <a16:creationId xmlns:a16="http://schemas.microsoft.com/office/drawing/2014/main" id="{57239DA3-FF3C-4401-B7DE-8CB58F77E6E5}"/>
               </a:ext>
             </a:extLst>
           </p:cNvPr>
@@ -3733,7 +3733,7 @@
         <p:spPr>
           <a:xfrm xmlns:a="http://schemas.openxmlformats.org/drawingml/2006/main">
             <a:off x="457200" y="800100"/>
-            <a:ext cx="7905750" cy="876300"/>
+            <a:ext cx="8096250" cy="876300"/>
           </a:xfrm>
           <a:prstGeom xmlns:a="http://schemas.openxmlformats.org/drawingml/2006/main" prst="rect">
             <a:avLst/>
@@ -3756,7 +3756,7 @@
               </a:defRPr>
             </a:pPr>
             <a:r>
-              <a:t>Four workstreams convert intent into manager routines.</a:t>
+              <a:t>Four workstreams convert intent into SRIB manager routines.</a:t>
             </a:r>
           </a:p>
         </p:txBody>
@@ -3766,7 +3766,7 @@
           <p:cNvPr id="5" name="">
             <a:extLst xmlns:a="http://schemas.openxmlformats.org/drawingml/2006/main">
               <a:ext uri="{FF2B5EF4-FFF2-40B4-BE49-F238E27FC236}">
-                <a16:creationId xmlns:a16="http://schemas.microsoft.com/office/drawing/2014/main" id="{317FD587-BCC9-4E4D-BBBC-6DFE62AA3EAC}"/>
+                <a16:creationId xmlns:a16="http://schemas.microsoft.com/office/drawing/2014/main" id="{CAD17974-EBAA-4047-AB06-6970BD80CC68}"/>
               </a:ext>
             </a:extLst>
           </p:cNvPr>
@@ -3778,7 +3778,7 @@
         <p:spPr>
           <a:xfrm xmlns:a="http://schemas.openxmlformats.org/drawingml/2006/main">
             <a:off x="476250" y="1752600"/>
-            <a:ext cx="7239000" cy="533400"/>
+            <a:ext cx="7667625" cy="552450"/>
           </a:xfrm>
           <a:prstGeom xmlns:a="http://schemas.openxmlformats.org/drawingml/2006/main" prst="rect">
             <a:avLst/>
@@ -3801,7 +3801,7 @@
               </a:defRPr>
             </a:pPr>
             <a:r>
-              <a:t>Each workstream has a concrete artifact, operating rhythm, and owner group so the initiative is easier to scale.</a:t>
+              <a:t>Each workstream has a concrete artifact, operating rhythm, and owner group so the initiative can scale across SRIB teams.</a:t>
             </a:r>
           </a:p>
         </p:txBody>
@@ -3811,7 +3811,7 @@
           <p:cNvPr id="6" name="">
             <a:extLst xmlns:a="http://schemas.openxmlformats.org/drawingml/2006/main">
               <a:ext uri="{FF2B5EF4-FFF2-40B4-BE49-F238E27FC236}">
-                <a16:creationId xmlns:a16="http://schemas.microsoft.com/office/drawing/2014/main" id="{75620731-CCC0-4AEE-AE3D-A19D8E020CBA}"/>
+                <a16:creationId xmlns:a16="http://schemas.microsoft.com/office/drawing/2014/main" id="{C050B8CB-93FE-420B-9A6B-860A66D4066C}"/>
               </a:ext>
             </a:extLst>
           </p:cNvPr>
@@ -3840,7 +3840,7 @@
           <p:cNvPr id="7" name="">
             <a:extLst xmlns:a="http://schemas.openxmlformats.org/drawingml/2006/main">
               <a:ext uri="{FF2B5EF4-FFF2-40B4-BE49-F238E27FC236}">
-                <a16:creationId xmlns:a16="http://schemas.microsoft.com/office/drawing/2014/main" id="{90848EA5-0C64-4706-ADE5-C4B14FFD3EFD}"/>
+                <a16:creationId xmlns:a16="http://schemas.microsoft.com/office/drawing/2014/main" id="{80B5C701-DF66-4303-9E40-41C077D41609}"/>
               </a:ext>
             </a:extLst>
           </p:cNvPr>
@@ -3869,7 +3869,7 @@
           <p:cNvPr id="8" name="">
             <a:extLst xmlns:a="http://schemas.openxmlformats.org/drawingml/2006/main">
               <a:ext uri="{FF2B5EF4-FFF2-40B4-BE49-F238E27FC236}">
-                <a16:creationId xmlns:a16="http://schemas.microsoft.com/office/drawing/2014/main" id="{921511A5-B91F-4E0E-9526-B615DC8A1E62}"/>
+                <a16:creationId xmlns:a16="http://schemas.microsoft.com/office/drawing/2014/main" id="{1DD0CF23-9F69-4D76-AA00-6B44F09BE3F7}"/>
               </a:ext>
             </a:extLst>
           </p:cNvPr>
@@ -3914,7 +3914,7 @@
           <p:cNvPr id="9" name="">
             <a:extLst xmlns:a="http://schemas.openxmlformats.org/drawingml/2006/main">
               <a:ext uri="{FF2B5EF4-FFF2-40B4-BE49-F238E27FC236}">
-                <a16:creationId xmlns:a16="http://schemas.microsoft.com/office/drawing/2014/main" id="{5C57D71A-47B3-402A-BD64-30D6DE3E1FC7}"/>
+                <a16:creationId xmlns:a16="http://schemas.microsoft.com/office/drawing/2014/main" id="{A3A5485F-36C9-49E9-9CC8-628A210A0E46}"/>
               </a:ext>
             </a:extLst>
           </p:cNvPr>
@@ -3959,7 +3959,7 @@
           <p:cNvPr id="10" name="">
             <a:extLst xmlns:a="http://schemas.openxmlformats.org/drawingml/2006/main">
               <a:ext uri="{FF2B5EF4-FFF2-40B4-BE49-F238E27FC236}">
-                <a16:creationId xmlns:a16="http://schemas.microsoft.com/office/drawing/2014/main" id="{42A61640-B9AB-4428-AC9A-F240E11281BC}"/>
+                <a16:creationId xmlns:a16="http://schemas.microsoft.com/office/drawing/2014/main" id="{8353288D-E56B-4416-AF07-AA679C591B7B}"/>
               </a:ext>
             </a:extLst>
           </p:cNvPr>
@@ -3988,7 +3988,7 @@
           <p:cNvPr id="11" name="">
             <a:extLst xmlns:a="http://schemas.openxmlformats.org/drawingml/2006/main">
               <a:ext uri="{FF2B5EF4-FFF2-40B4-BE49-F238E27FC236}">
-                <a16:creationId xmlns:a16="http://schemas.microsoft.com/office/drawing/2014/main" id="{96BF396D-0A62-4AE1-A7F1-A23F659BCBF6}"/>
+                <a16:creationId xmlns:a16="http://schemas.microsoft.com/office/drawing/2014/main" id="{59F872DF-CD82-4659-A103-496B1DAEC89B}"/>
               </a:ext>
             </a:extLst>
           </p:cNvPr>
@@ -4017,7 +4017,7 @@
           <p:cNvPr id="12" name="">
             <a:extLst xmlns:a="http://schemas.openxmlformats.org/drawingml/2006/main">
               <a:ext uri="{FF2B5EF4-FFF2-40B4-BE49-F238E27FC236}">
-                <a16:creationId xmlns:a16="http://schemas.microsoft.com/office/drawing/2014/main" id="{793C82AB-6B85-4F8B-A9FE-F3CC7747E96E}"/>
+                <a16:creationId xmlns:a16="http://schemas.microsoft.com/office/drawing/2014/main" id="{5F3335FC-CDEA-40E5-86C6-22C7566652CD}"/>
               </a:ext>
             </a:extLst>
           </p:cNvPr>
@@ -4062,7 +4062,7 @@
           <p:cNvPr id="13" name="">
             <a:extLst xmlns:a="http://schemas.openxmlformats.org/drawingml/2006/main">
               <a:ext uri="{FF2B5EF4-FFF2-40B4-BE49-F238E27FC236}">
-                <a16:creationId xmlns:a16="http://schemas.microsoft.com/office/drawing/2014/main" id="{B01416E0-5E77-4022-A86D-B94CFEBCF17C}"/>
+                <a16:creationId xmlns:a16="http://schemas.microsoft.com/office/drawing/2014/main" id="{6C1408F5-A87B-4E65-8C6F-C637422F4EB0}"/>
               </a:ext>
             </a:extLst>
           </p:cNvPr>
@@ -4107,7 +4107,7 @@
           <p:cNvPr id="14" name="">
             <a:extLst xmlns:a="http://schemas.openxmlformats.org/drawingml/2006/main">
               <a:ext uri="{FF2B5EF4-FFF2-40B4-BE49-F238E27FC236}">
-                <a16:creationId xmlns:a16="http://schemas.microsoft.com/office/drawing/2014/main" id="{938D627F-2D9B-469C-8942-3375C76DB8E9}"/>
+                <a16:creationId xmlns:a16="http://schemas.microsoft.com/office/drawing/2014/main" id="{C04C6B43-47FA-4546-B256-30487D2F5863}"/>
               </a:ext>
             </a:extLst>
           </p:cNvPr>
@@ -4136,7 +4136,7 @@
           <p:cNvPr id="15" name="">
             <a:extLst xmlns:a="http://schemas.openxmlformats.org/drawingml/2006/main">
               <a:ext uri="{FF2B5EF4-FFF2-40B4-BE49-F238E27FC236}">
-                <a16:creationId xmlns:a16="http://schemas.microsoft.com/office/drawing/2014/main" id="{12F10AF9-784D-458D-9431-97A1076D7E38}"/>
+                <a16:creationId xmlns:a16="http://schemas.microsoft.com/office/drawing/2014/main" id="{F8C65CE7-63E6-45C6-AB08-C4C9EED2B4D5}"/>
               </a:ext>
             </a:extLst>
           </p:cNvPr>
@@ -4165,7 +4165,7 @@
           <p:cNvPr id="16" name="">
             <a:extLst xmlns:a="http://schemas.openxmlformats.org/drawingml/2006/main">
               <a:ext uri="{FF2B5EF4-FFF2-40B4-BE49-F238E27FC236}">
-                <a16:creationId xmlns:a16="http://schemas.microsoft.com/office/drawing/2014/main" id="{CD3A0104-DB83-4CAC-9566-1DF89137C004}"/>
+                <a16:creationId xmlns:a16="http://schemas.microsoft.com/office/drawing/2014/main" id="{02649DDA-030E-47E1-AAD1-9308E75C1567}"/>
               </a:ext>
             </a:extLst>
           </p:cNvPr>
@@ -4210,7 +4210,7 @@
           <p:cNvPr id="17" name="">
             <a:extLst xmlns:a="http://schemas.openxmlformats.org/drawingml/2006/main">
               <a:ext uri="{FF2B5EF4-FFF2-40B4-BE49-F238E27FC236}">
-                <a16:creationId xmlns:a16="http://schemas.microsoft.com/office/drawing/2014/main" id="{D7D1394B-251E-4A2A-BA0C-54DAD2617B39}"/>
+                <a16:creationId xmlns:a16="http://schemas.microsoft.com/office/drawing/2014/main" id="{0B3BEFF9-B9E5-4F4E-9678-4CA528CF627B}"/>
               </a:ext>
             </a:extLst>
           </p:cNvPr>
@@ -4245,7 +4245,7 @@
               </a:defRPr>
             </a:pPr>
             <a:r>
-              <a:t>Ready-to-use 1:1 templates, team charter canvas, difficult conversation guides, onboarding checklists, and pulse survey packs.</a:t>
+              <a:t>SRIB-ready 1:1 templates, team charter canvas, difficult conversation guides, onboarding checklists, and pulse survey packs.</a:t>
             </a:r>
           </a:p>
         </p:txBody>
@@ -4255,7 +4255,7 @@
           <p:cNvPr id="18" name="">
             <a:extLst xmlns:a="http://schemas.openxmlformats.org/drawingml/2006/main">
               <a:ext uri="{FF2B5EF4-FFF2-40B4-BE49-F238E27FC236}">
-                <a16:creationId xmlns:a16="http://schemas.microsoft.com/office/drawing/2014/main" id="{A255A551-87BC-4FDE-B2FE-E2CD122ABCE5}"/>
+                <a16:creationId xmlns:a16="http://schemas.microsoft.com/office/drawing/2014/main" id="{E8B335AD-BD15-473F-974B-DD38848E493D}"/>
               </a:ext>
             </a:extLst>
           </p:cNvPr>
@@ -4284,7 +4284,7 @@
           <p:cNvPr id="19" name="">
             <a:extLst xmlns:a="http://schemas.openxmlformats.org/drawingml/2006/main">
               <a:ext uri="{FF2B5EF4-FFF2-40B4-BE49-F238E27FC236}">
-                <a16:creationId xmlns:a16="http://schemas.microsoft.com/office/drawing/2014/main" id="{BF5DE118-3607-484E-BC2E-8B71C10D8D94}"/>
+                <a16:creationId xmlns:a16="http://schemas.microsoft.com/office/drawing/2014/main" id="{DEE3E1AB-3D41-4F20-BEC7-EB54A2F29792}"/>
               </a:ext>
             </a:extLst>
           </p:cNvPr>
@@ -4313,7 +4313,7 @@
           <p:cNvPr id="20" name="">
             <a:extLst xmlns:a="http://schemas.openxmlformats.org/drawingml/2006/main">
               <a:ext uri="{FF2B5EF4-FFF2-40B4-BE49-F238E27FC236}">
-                <a16:creationId xmlns:a16="http://schemas.microsoft.com/office/drawing/2014/main" id="{FEC8052E-E1A3-4983-AEFD-D30ECFC9D0A6}"/>
+                <a16:creationId xmlns:a16="http://schemas.microsoft.com/office/drawing/2014/main" id="{3E636F59-F5F3-4448-A3FE-3070ACE9D174}"/>
               </a:ext>
             </a:extLst>
           </p:cNvPr>
@@ -4358,7 +4358,7 @@
           <p:cNvPr id="21" name="">
             <a:extLst xmlns:a="http://schemas.openxmlformats.org/drawingml/2006/main">
               <a:ext uri="{FF2B5EF4-FFF2-40B4-BE49-F238E27FC236}">
-                <a16:creationId xmlns:a16="http://schemas.microsoft.com/office/drawing/2014/main" id="{5841BC62-A2D7-40A5-A71D-2AD0E26E746A}"/>
+                <a16:creationId xmlns:a16="http://schemas.microsoft.com/office/drawing/2014/main" id="{3FE0C579-26C4-4387-854D-8E1ED4D5A580}"/>
               </a:ext>
             </a:extLst>
           </p:cNvPr>
@@ -4393,7 +4393,7 @@
               </a:defRPr>
             </a:pPr>
             <a:r>
-              <a:t>Leaders facilitate small circles, walk-and-talks, case clinics, and peer learning to make leadership development local.</a:t>
+              <a:t>Leaders facilitate small circles, walk-and-talks, case clinics, and peer learning to make development local and practical.</a:t>
             </a:r>
           </a:p>
         </p:txBody>
@@ -4403,7 +4403,7 @@
           <p:cNvPr id="22" name="">
             <a:extLst xmlns:a="http://schemas.openxmlformats.org/drawingml/2006/main">
               <a:ext uri="{FF2B5EF4-FFF2-40B4-BE49-F238E27FC236}">
-                <a16:creationId xmlns:a16="http://schemas.microsoft.com/office/drawing/2014/main" id="{DF0BDFDF-910A-49F5-8769-B0ED20418C21}"/>
+                <a16:creationId xmlns:a16="http://schemas.microsoft.com/office/drawing/2014/main" id="{AF96E527-4DC2-4831-8567-8440692E42AC}"/>
               </a:ext>
             </a:extLst>
           </p:cNvPr>
@@ -4432,7 +4432,7 @@
           <p:cNvPr id="23" name="">
             <a:extLst xmlns:a="http://schemas.openxmlformats.org/drawingml/2006/main">
               <a:ext uri="{FF2B5EF4-FFF2-40B4-BE49-F238E27FC236}">
-                <a16:creationId xmlns:a16="http://schemas.microsoft.com/office/drawing/2014/main" id="{6B2431EA-F3B6-4C1C-9789-548EFF4DB07B}"/>
+                <a16:creationId xmlns:a16="http://schemas.microsoft.com/office/drawing/2014/main" id="{CA245356-5495-4511-A289-2BA7C431E8A7}"/>
               </a:ext>
             </a:extLst>
           </p:cNvPr>
@@ -4444,7 +4444,7 @@
         <p:spPr>
           <a:xfrm xmlns:a="http://schemas.openxmlformats.org/drawingml/2006/main">
             <a:off x="781050" y="5800725"/>
-            <a:ext cx="8763000" cy="190500"/>
+            <a:ext cx="9334500" cy="190500"/>
           </a:xfrm>
           <a:prstGeom xmlns:a="http://schemas.openxmlformats.org/drawingml/2006/main" prst="rect">
             <a:avLst/>
@@ -4467,7 +4467,7 @@
               </a:defRPr>
             </a:pPr>
             <a:r>
-              <a:t>Design principle: every theme should become a repeatable manager ritual, not a one-time workshop.</a:t>
+              <a:t>Design principle: every theme becomes a repeatable SRIB manager ritual by December 2026, not a one-time workshop.</a:t>
             </a:r>
           </a:p>
         </p:txBody>
@@ -4477,7 +4477,7 @@
           <p:cNvPr id="24" name="">
             <a:extLst xmlns:a="http://schemas.openxmlformats.org/drawingml/2006/main">
               <a:ext uri="{FF2B5EF4-FFF2-40B4-BE49-F238E27FC236}">
-                <a16:creationId xmlns:a16="http://schemas.microsoft.com/office/drawing/2014/main" id="{3E29433C-CAFB-4D45-9A0E-19D33E93179E}"/>
+                <a16:creationId xmlns:a16="http://schemas.microsoft.com/office/drawing/2014/main" id="{DC5BC7CC-CEB3-4FC0-BA61-E5A9720A034A}"/>
               </a:ext>
             </a:extLst>
           </p:cNvPr>
@@ -4489,7 +4489,7 @@
         <p:spPr>
           <a:xfrm xmlns:a="http://schemas.openxmlformats.org/drawingml/2006/main">
             <a:off x="457200" y="6438900"/>
-            <a:ext cx="6858000" cy="171450"/>
+            <a:ext cx="7239000" cy="171450"/>
           </a:xfrm>
           <a:prstGeom xmlns:a="http://schemas.openxmlformats.org/drawingml/2006/main" prst="rect">
             <a:avLst/>
@@ -4512,7 +4512,7 @@
               </a:defRPr>
             </a:pPr>
             <a:r>
-              <a:t>Leadership Task Force | Manager Effectiveness and Everyday Leadership | Samsung India</a:t>
+              <a:t>Samsung R&amp;D Institute Bangalore | SRIB Managers and Employees | June-Dec 2026</a:t>
             </a:r>
           </a:p>
         </p:txBody>
@@ -4520,7 +4520,7 @@
     </p:spTree>
     <p:extLst>
       <p:ext uri="{BB962C8B-B14F-4D97-AF65-F5344CB8AC3E}">
-        <p14:creationId xmlns:p14="http://schemas.microsoft.com/office/powerpoint/2010/main" val="94794400"/>
+        <p14:creationId xmlns:p14="http://schemas.microsoft.com/office/powerpoint/2010/main" val="869386566"/>
       </p:ext>
     </p:extLst>
   </p:cSld>
@@ -4551,7 +4551,7 @@
           <p:cNvPr id="1" name="">
             <a:extLst xmlns:a="http://schemas.openxmlformats.org/drawingml/2006/main">
               <a:ext uri="{FF2B5EF4-FFF2-40B4-BE49-F238E27FC236}">
-                <a16:creationId xmlns:a16="http://schemas.microsoft.com/office/drawing/2014/main" id="{C815369E-7964-4B3D-8B13-35A16AA3C3CB}"/>
+                <a16:creationId xmlns:a16="http://schemas.microsoft.com/office/drawing/2014/main" id="{BAB8D7D3-6E03-4397-BFE2-72D6D31FE687}"/>
               </a:ext>
             </a:extLst>
           </p:cNvPr>
@@ -4580,7 +4580,7 @@
           <p:cNvPr id="2" name="">
             <a:extLst xmlns:a="http://schemas.openxmlformats.org/drawingml/2006/main">
               <a:ext uri="{FF2B5EF4-FFF2-40B4-BE49-F238E27FC236}">
-                <a16:creationId xmlns:a16="http://schemas.microsoft.com/office/drawing/2014/main" id="{98C1BD25-A545-4417-8FBD-4384EA383D25}"/>
+                <a16:creationId xmlns:a16="http://schemas.microsoft.com/office/drawing/2014/main" id="{2C94102D-396B-4F0D-B32D-53019AC63531}"/>
               </a:ext>
             </a:extLst>
           </p:cNvPr>
@@ -4592,7 +4592,7 @@
         <p:spPr>
           <a:xfrm xmlns:a="http://schemas.openxmlformats.org/drawingml/2006/main">
             <a:off x="647700" y="361950"/>
-            <a:ext cx="4000500" cy="266700"/>
+            <a:ext cx="4953000" cy="266700"/>
           </a:xfrm>
           <a:prstGeom xmlns:a="http://schemas.openxmlformats.org/drawingml/2006/main" prst="rect">
             <a:avLst/>
@@ -4625,7 +4625,7 @@
           <p:cNvPr id="3" name="">
             <a:extLst xmlns:a="http://schemas.openxmlformats.org/drawingml/2006/main">
               <a:ext uri="{FF2B5EF4-FFF2-40B4-BE49-F238E27FC236}">
-                <a16:creationId xmlns:a16="http://schemas.microsoft.com/office/drawing/2014/main" id="{AC71C1F8-1D02-42BD-830C-EE4C2AEBAC22}"/>
+                <a16:creationId xmlns:a16="http://schemas.microsoft.com/office/drawing/2014/main" id="{16D33211-9F41-46A8-858D-907CA7431B13}"/>
               </a:ext>
             </a:extLst>
           </p:cNvPr>
@@ -4670,7 +4670,7 @@
           <p:cNvPr id="4" name="">
             <a:extLst xmlns:a="http://schemas.openxmlformats.org/drawingml/2006/main">
               <a:ext uri="{FF2B5EF4-FFF2-40B4-BE49-F238E27FC236}">
-                <a16:creationId xmlns:a16="http://schemas.microsoft.com/office/drawing/2014/main" id="{CD858F55-C9A1-4A83-A63D-726EC709C09A}"/>
+                <a16:creationId xmlns:a16="http://schemas.microsoft.com/office/drawing/2014/main" id="{9EA26CF8-C39F-4D73-A676-E9DB1EC99CD0}"/>
               </a:ext>
             </a:extLst>
           </p:cNvPr>
@@ -4682,7 +4682,7 @@
         <p:spPr>
           <a:xfrm xmlns:a="http://schemas.openxmlformats.org/drawingml/2006/main">
             <a:off x="457200" y="800100"/>
-            <a:ext cx="7905750" cy="876300"/>
+            <a:ext cx="8096250" cy="876300"/>
           </a:xfrm>
           <a:prstGeom xmlns:a="http://schemas.openxmlformats.org/drawingml/2006/main" prst="rect">
             <a:avLst/>
@@ -4705,7 +4705,7 @@
               </a:defRPr>
             </a:pPr>
             <a:r>
-              <a:t>Build with LMD, pilot with managers, scale through leaders.</a:t>
+              <a:t>Build with LMD, pilot inside SRIB, scale through leaders.</a:t>
             </a:r>
           </a:p>
         </p:txBody>
@@ -4715,7 +4715,7 @@
           <p:cNvPr id="5" name="">
             <a:extLst xmlns:a="http://schemas.openxmlformats.org/drawingml/2006/main">
               <a:ext uri="{FF2B5EF4-FFF2-40B4-BE49-F238E27FC236}">
-                <a16:creationId xmlns:a16="http://schemas.microsoft.com/office/drawing/2014/main" id="{4D5A4D7D-FE06-4F8B-8603-05ECD3F631A8}"/>
+                <a16:creationId xmlns:a16="http://schemas.microsoft.com/office/drawing/2014/main" id="{BCE48199-FBDB-4148-9E63-7C239B835546}"/>
               </a:ext>
             </a:extLst>
           </p:cNvPr>
@@ -4727,7 +4727,7 @@
         <p:spPr>
           <a:xfrm xmlns:a="http://schemas.openxmlformats.org/drawingml/2006/main">
             <a:off x="476250" y="1752600"/>
-            <a:ext cx="7239000" cy="533400"/>
+            <a:ext cx="7667625" cy="552450"/>
           </a:xfrm>
           <a:prstGeom xmlns:a="http://schemas.openxmlformats.org/drawingml/2006/main" prst="rect">
             <a:avLst/>
@@ -4750,7 +4750,7 @@
               </a:defRPr>
             </a:pPr>
             <a:r>
-              <a:t>The task force should own direction and governance while LMD strengthens design, facilitation, and manager transition support.</a:t>
+              <a:t>The task force owns direction and governance while LMD strengthens design, facilitation, and first-time manager transition support.</a:t>
             </a:r>
           </a:p>
         </p:txBody>
@@ -4760,7 +4760,7 @@
           <p:cNvPr id="6" name="">
             <a:extLst xmlns:a="http://schemas.openxmlformats.org/drawingml/2006/main">
               <a:ext uri="{FF2B5EF4-FFF2-40B4-BE49-F238E27FC236}">
-                <a16:creationId xmlns:a16="http://schemas.microsoft.com/office/drawing/2014/main" id="{8C15F518-E921-46DB-8671-94248C5FCBE7}"/>
+                <a16:creationId xmlns:a16="http://schemas.microsoft.com/office/drawing/2014/main" id="{9983063D-A984-4F08-85E4-F07DE9CA4624}"/>
               </a:ext>
             </a:extLst>
           </p:cNvPr>
@@ -4789,7 +4789,7 @@
           <p:cNvPr id="7" name="">
             <a:extLst xmlns:a="http://schemas.openxmlformats.org/drawingml/2006/main">
               <a:ext uri="{FF2B5EF4-FFF2-40B4-BE49-F238E27FC236}">
-                <a16:creationId xmlns:a16="http://schemas.microsoft.com/office/drawing/2014/main" id="{2766AA6B-05AB-43A3-A449-44FE2EB0E06E}"/>
+                <a16:creationId xmlns:a16="http://schemas.microsoft.com/office/drawing/2014/main" id="{43429260-D859-4A9C-A952-8AEC5FB77D87}"/>
               </a:ext>
             </a:extLst>
           </p:cNvPr>
@@ -4824,7 +4824,7 @@
               </a:defRPr>
             </a:pPr>
             <a:r>
-              <a:t>Task Force</a:t>
+              <a:t>SRIB Task Force</a:t>
             </a:r>
           </a:p>
         </p:txBody>
@@ -4834,7 +4834,7 @@
           <p:cNvPr id="8" name="">
             <a:extLst xmlns:a="http://schemas.openxmlformats.org/drawingml/2006/main">
               <a:ext uri="{FF2B5EF4-FFF2-40B4-BE49-F238E27FC236}">
-                <a16:creationId xmlns:a16="http://schemas.microsoft.com/office/drawing/2014/main" id="{9B4857B7-9B41-42C8-8498-9DD304AE38CC}"/>
+                <a16:creationId xmlns:a16="http://schemas.microsoft.com/office/drawing/2014/main" id="{8866B063-6F92-4481-B6FA-D99FFD824D63}"/>
               </a:ext>
             </a:extLst>
           </p:cNvPr>
@@ -4879,7 +4879,7 @@
           <p:cNvPr id="9" name="">
             <a:extLst xmlns:a="http://schemas.openxmlformats.org/drawingml/2006/main">
               <a:ext uri="{FF2B5EF4-FFF2-40B4-BE49-F238E27FC236}">
-                <a16:creationId xmlns:a16="http://schemas.microsoft.com/office/drawing/2014/main" id="{5D904C6B-BF5E-4F3B-B0FE-0BFD0F5995C8}"/>
+                <a16:creationId xmlns:a16="http://schemas.microsoft.com/office/drawing/2014/main" id="{E452F143-4654-434E-B259-3B3F043E5E29}"/>
               </a:ext>
             </a:extLst>
           </p:cNvPr>
@@ -4908,7 +4908,7 @@
           <p:cNvPr id="10" name="">
             <a:extLst xmlns:a="http://schemas.openxmlformats.org/drawingml/2006/main">
               <a:ext uri="{FF2B5EF4-FFF2-40B4-BE49-F238E27FC236}">
-                <a16:creationId xmlns:a16="http://schemas.microsoft.com/office/drawing/2014/main" id="{4A032888-901D-4622-9364-5DFE4435A5CB}"/>
+                <a16:creationId xmlns:a16="http://schemas.microsoft.com/office/drawing/2014/main" id="{4D13860F-7327-446C-BC6A-6FA36A02158D}"/>
               </a:ext>
             </a:extLst>
           </p:cNvPr>
@@ -4953,7 +4953,7 @@
           <p:cNvPr id="11" name="">
             <a:extLst xmlns:a="http://schemas.openxmlformats.org/drawingml/2006/main">
               <a:ext uri="{FF2B5EF4-FFF2-40B4-BE49-F238E27FC236}">
-                <a16:creationId xmlns:a16="http://schemas.microsoft.com/office/drawing/2014/main" id="{CDB5F354-7638-4DD5-8AB8-A56D803E66B8}"/>
+                <a16:creationId xmlns:a16="http://schemas.microsoft.com/office/drawing/2014/main" id="{35B3A3DC-2C34-45AB-9DE2-9F37D5FF2571}"/>
               </a:ext>
             </a:extLst>
           </p:cNvPr>
@@ -4988,7 +4988,7 @@
               </a:defRPr>
             </a:pPr>
             <a:r>
-              <a:t>Co-design manager curriculum, toolkits, learning circles, and first-time manager pathway.</a:t>
+              <a:t>Co-design curriculum, toolkits, learning circles, and first-time manager pathway.</a:t>
             </a:r>
           </a:p>
         </p:txBody>
@@ -4998,7 +4998,7 @@
           <p:cNvPr id="12" name="">
             <a:extLst xmlns:a="http://schemas.openxmlformats.org/drawingml/2006/main">
               <a:ext uri="{FF2B5EF4-FFF2-40B4-BE49-F238E27FC236}">
-                <a16:creationId xmlns:a16="http://schemas.microsoft.com/office/drawing/2014/main" id="{A9C45B57-B427-4C00-BE18-EA7164F6302D}"/>
+                <a16:creationId xmlns:a16="http://schemas.microsoft.com/office/drawing/2014/main" id="{327035D1-8939-416A-AC55-7664A82A1FD4}"/>
               </a:ext>
             </a:extLst>
           </p:cNvPr>
@@ -5027,7 +5027,7 @@
           <p:cNvPr id="13" name="">
             <a:extLst xmlns:a="http://schemas.openxmlformats.org/drawingml/2006/main">
               <a:ext uri="{FF2B5EF4-FFF2-40B4-BE49-F238E27FC236}">
-                <a16:creationId xmlns:a16="http://schemas.microsoft.com/office/drawing/2014/main" id="{762E2B1A-5927-4C94-827B-D8C32F9ECF6A}"/>
+                <a16:creationId xmlns:a16="http://schemas.microsoft.com/office/drawing/2014/main" id="{D383C15A-1475-4CF8-98E1-A0626D07C7B1}"/>
               </a:ext>
             </a:extLst>
           </p:cNvPr>
@@ -5072,7 +5072,7 @@
           <p:cNvPr id="14" name="">
             <a:extLst xmlns:a="http://schemas.openxmlformats.org/drawingml/2006/main">
               <a:ext uri="{FF2B5EF4-FFF2-40B4-BE49-F238E27FC236}">
-                <a16:creationId xmlns:a16="http://schemas.microsoft.com/office/drawing/2014/main" id="{364ACD1E-A9E9-4689-86FE-EFD6425714F4}"/>
+                <a16:creationId xmlns:a16="http://schemas.microsoft.com/office/drawing/2014/main" id="{23B5437A-19CD-49DB-B11F-57B4289F65BF}"/>
               </a:ext>
             </a:extLst>
           </p:cNvPr>
@@ -5107,7 +5107,7 @@
               </a:defRPr>
             </a:pPr>
             <a:r>
-              <a:t>Model behaviors, sponsor learning circles, identify pilot teams, review adoption data.</a:t>
+              <a:t>Model behaviors, sponsor circles, identify pilot teams, review adoption data.</a:t>
             </a:r>
           </a:p>
         </p:txBody>
@@ -5117,7 +5117,7 @@
           <p:cNvPr id="15" name="">
             <a:extLst xmlns:a="http://schemas.openxmlformats.org/drawingml/2006/main">
               <a:ext uri="{FF2B5EF4-FFF2-40B4-BE49-F238E27FC236}">
-                <a16:creationId xmlns:a16="http://schemas.microsoft.com/office/drawing/2014/main" id="{F73A1768-A5A8-4DE3-AC14-238E3E001688}"/>
+                <a16:creationId xmlns:a16="http://schemas.microsoft.com/office/drawing/2014/main" id="{263FBB5C-42C1-4505-A0B0-A7BBB9B58A4D}"/>
               </a:ext>
             </a:extLst>
           </p:cNvPr>
@@ -5146,7 +5146,7 @@
           <p:cNvPr id="16" name="">
             <a:extLst xmlns:a="http://schemas.openxmlformats.org/drawingml/2006/main">
               <a:ext uri="{FF2B5EF4-FFF2-40B4-BE49-F238E27FC236}">
-                <a16:creationId xmlns:a16="http://schemas.microsoft.com/office/drawing/2014/main" id="{EB7D2A17-6521-412B-B0BB-F8749D424DE5}"/>
+                <a16:creationId xmlns:a16="http://schemas.microsoft.com/office/drawing/2014/main" id="{2B786596-5FDA-4A00-9AD8-41B455A8D2B6}"/>
               </a:ext>
             </a:extLst>
           </p:cNvPr>
@@ -5191,7 +5191,7 @@
           <p:cNvPr id="17" name="">
             <a:extLst xmlns:a="http://schemas.openxmlformats.org/drawingml/2006/main">
               <a:ext uri="{FF2B5EF4-FFF2-40B4-BE49-F238E27FC236}">
-                <a16:creationId xmlns:a16="http://schemas.microsoft.com/office/drawing/2014/main" id="{9CC0F3EA-AED9-4928-A91A-3399BD5FD4CD}"/>
+                <a16:creationId xmlns:a16="http://schemas.microsoft.com/office/drawing/2014/main" id="{89257775-FF1C-4F3B-B046-F724CE0CFCF2}"/>
               </a:ext>
             </a:extLst>
           </p:cNvPr>
@@ -5226,7 +5226,7 @@
               </a:defRPr>
             </a:pPr>
             <a:r>
-              <a:t>Run rituals: 1:1s, feedback moments, team huddles, debriefs, and coaching conversations.</a:t>
+              <a:t>Run rituals: 1:1s, feedback moments, huddles, debriefs, and coaching conversations.</a:t>
             </a:r>
           </a:p>
         </p:txBody>
@@ -5236,7 +5236,7 @@
           <p:cNvPr id="18" name="">
             <a:extLst xmlns:a="http://schemas.openxmlformats.org/drawingml/2006/main">
               <a:ext uri="{FF2B5EF4-FFF2-40B4-BE49-F238E27FC236}">
-                <a16:creationId xmlns:a16="http://schemas.microsoft.com/office/drawing/2014/main" id="{41CA009F-869A-4917-8CE5-D9B66B3DDB8D}"/>
+                <a16:creationId xmlns:a16="http://schemas.microsoft.com/office/drawing/2014/main" id="{50A00BEB-2C8F-429E-9CF0-4B2C6F3B4B92}"/>
               </a:ext>
             </a:extLst>
           </p:cNvPr>
@@ -5265,7 +5265,7 @@
           <p:cNvPr id="19" name="">
             <a:extLst xmlns:a="http://schemas.openxmlformats.org/drawingml/2006/main">
               <a:ext uri="{FF2B5EF4-FFF2-40B4-BE49-F238E27FC236}">
-                <a16:creationId xmlns:a16="http://schemas.microsoft.com/office/drawing/2014/main" id="{335A3C75-0548-4F09-9EC9-E6054E2C11D6}"/>
+                <a16:creationId xmlns:a16="http://schemas.microsoft.com/office/drawing/2014/main" id="{44853BB7-86C2-4924-AA3B-1F8CF3B6F88C}"/>
               </a:ext>
             </a:extLst>
           </p:cNvPr>
@@ -5310,7 +5310,7 @@
           <p:cNvPr id="20" name="">
             <a:extLst xmlns:a="http://schemas.openxmlformats.org/drawingml/2006/main">
               <a:ext uri="{FF2B5EF4-FFF2-40B4-BE49-F238E27FC236}">
-                <a16:creationId xmlns:a16="http://schemas.microsoft.com/office/drawing/2014/main" id="{0E1494FC-F3AF-4F3B-8E9D-525E36F6B786}"/>
+                <a16:creationId xmlns:a16="http://schemas.microsoft.com/office/drawing/2014/main" id="{B9EE601C-6EB7-4662-9D0D-000F16E0F740}"/>
               </a:ext>
             </a:extLst>
           </p:cNvPr>
@@ -5339,7 +5339,7 @@
           <p:cNvPr id="21" name="">
             <a:extLst xmlns:a="http://schemas.openxmlformats.org/drawingml/2006/main">
               <a:ext uri="{FF2B5EF4-FFF2-40B4-BE49-F238E27FC236}">
-                <a16:creationId xmlns:a16="http://schemas.microsoft.com/office/drawing/2014/main" id="{9CE9E6D4-B049-4532-B824-4197F64592B4}"/>
+                <a16:creationId xmlns:a16="http://schemas.microsoft.com/office/drawing/2014/main" id="{D1E31505-6BEA-4F6A-BA18-EC1638EFFD3E}"/>
               </a:ext>
             </a:extLst>
           </p:cNvPr>
@@ -5374,7 +5374,7 @@
               </a:defRPr>
             </a:pPr>
             <a:r>
-              <a:t>Pre-role orientation: expectations, people responsibilities, key moments in the first 90 days.</a:t>
+              <a:t>June-July: pre-role orientation on expectations, people responsibilities, and first 90-day moments.</a:t>
             </a:r>
           </a:p>
         </p:txBody>
@@ -5384,7 +5384,7 @@
           <p:cNvPr id="22" name="">
             <a:extLst xmlns:a="http://schemas.openxmlformats.org/drawingml/2006/main">
               <a:ext uri="{FF2B5EF4-FFF2-40B4-BE49-F238E27FC236}">
-                <a16:creationId xmlns:a16="http://schemas.microsoft.com/office/drawing/2014/main" id="{44DA4D1B-88E8-46E9-8D46-E4D1DE75BCFD}"/>
+                <a16:creationId xmlns:a16="http://schemas.microsoft.com/office/drawing/2014/main" id="{E92DC9B7-ECDB-4BD9-90AA-0DBDC14B7D56}"/>
               </a:ext>
             </a:extLst>
           </p:cNvPr>
@@ -5413,7 +5413,7 @@
           <p:cNvPr id="23" name="">
             <a:extLst xmlns:a="http://schemas.openxmlformats.org/drawingml/2006/main">
               <a:ext uri="{FF2B5EF4-FFF2-40B4-BE49-F238E27FC236}">
-                <a16:creationId xmlns:a16="http://schemas.microsoft.com/office/drawing/2014/main" id="{79FFCF30-07BE-42D2-80D6-71D82ADCF0EA}"/>
+                <a16:creationId xmlns:a16="http://schemas.microsoft.com/office/drawing/2014/main" id="{F4181922-C90D-45A5-B1E7-ACA43519AD08}"/>
               </a:ext>
             </a:extLst>
           </p:cNvPr>
@@ -5448,7 +5448,7 @@
               </a:defRPr>
             </a:pPr>
             <a:r>
-              <a:t>Buddy leader and LMD clinic: monthly case discussion, feedback practice, and escalation support.</a:t>
+              <a:t>August-December: buddy leader and LMD clinic for case discussion, feedback practice, and escalation support.</a:t>
             </a:r>
           </a:p>
         </p:txBody>
@@ -5458,7 +5458,7 @@
           <p:cNvPr id="24" name="">
             <a:extLst xmlns:a="http://schemas.openxmlformats.org/drawingml/2006/main">
               <a:ext uri="{FF2B5EF4-FFF2-40B4-BE49-F238E27FC236}">
-                <a16:creationId xmlns:a16="http://schemas.microsoft.com/office/drawing/2014/main" id="{03A46F88-2ED3-4C3F-A2D1-DE11A571651C}"/>
+                <a16:creationId xmlns:a16="http://schemas.microsoft.com/office/drawing/2014/main" id="{92B54A67-1A5A-45A5-B2A6-F687714C8F87}"/>
               </a:ext>
             </a:extLst>
           </p:cNvPr>
@@ -5487,7 +5487,7 @@
           <p:cNvPr id="25" name="">
             <a:extLst xmlns:a="http://schemas.openxmlformats.org/drawingml/2006/main">
               <a:ext uri="{FF2B5EF4-FFF2-40B4-BE49-F238E27FC236}">
-                <a16:creationId xmlns:a16="http://schemas.microsoft.com/office/drawing/2014/main" id="{43F67390-6E11-4B1D-81BA-B82E7EA6B625}"/>
+                <a16:creationId xmlns:a16="http://schemas.microsoft.com/office/drawing/2014/main" id="{C371B5D7-4D85-4BBB-BD7C-332294E18391}"/>
               </a:ext>
             </a:extLst>
           </p:cNvPr>
@@ -5499,7 +5499,7 @@
         <p:spPr>
           <a:xfrm xmlns:a="http://schemas.openxmlformats.org/drawingml/2006/main">
             <a:off x="1066800" y="5781675"/>
-            <a:ext cx="8953500" cy="190500"/>
+            <a:ext cx="9239250" cy="190500"/>
           </a:xfrm>
           <a:prstGeom xmlns:a="http://schemas.openxmlformats.org/drawingml/2006/main" prst="rect">
             <a:avLst/>
@@ -5522,7 +5522,7 @@
               </a:defRPr>
             </a:pPr>
             <a:r>
-              <a:t>Governance cadence: monthly adoption review, quarterly employee pulse, semi-annual capability refresh.</a:t>
+              <a:t>Governance cadence: monthly adoption review from June to December 2026, plus quarterly employee pulse.</a:t>
             </a:r>
           </a:p>
         </p:txBody>
@@ -5532,7 +5532,7 @@
           <p:cNvPr id="26" name="">
             <a:extLst xmlns:a="http://schemas.openxmlformats.org/drawingml/2006/main">
               <a:ext uri="{FF2B5EF4-FFF2-40B4-BE49-F238E27FC236}">
-                <a16:creationId xmlns:a16="http://schemas.microsoft.com/office/drawing/2014/main" id="{99020B18-18F7-47CE-B0C3-CE1E3DEA988C}"/>
+                <a16:creationId xmlns:a16="http://schemas.microsoft.com/office/drawing/2014/main" id="{4970737D-7930-4E1A-B1E0-0D6CE201787A}"/>
               </a:ext>
             </a:extLst>
           </p:cNvPr>
@@ -5544,7 +5544,7 @@
         <p:spPr>
           <a:xfrm xmlns:a="http://schemas.openxmlformats.org/drawingml/2006/main">
             <a:off x="457200" y="6438900"/>
-            <a:ext cx="6858000" cy="171450"/>
+            <a:ext cx="7239000" cy="171450"/>
           </a:xfrm>
           <a:prstGeom xmlns:a="http://schemas.openxmlformats.org/drawingml/2006/main" prst="rect">
             <a:avLst/>
@@ -5567,7 +5567,7 @@
               </a:defRPr>
             </a:pPr>
             <a:r>
-              <a:t>Leadership Task Force | Manager Effectiveness and Everyday Leadership | Samsung India</a:t>
+              <a:t>Samsung R&amp;D Institute Bangalore | SRIB Managers and Employees | June-Dec 2026</a:t>
             </a:r>
           </a:p>
         </p:txBody>
@@ -5575,7 +5575,7 @@
     </p:spTree>
     <p:extLst>
       <p:ext uri="{BB962C8B-B14F-4D97-AF65-F5344CB8AC3E}">
-        <p14:creationId xmlns:p14="http://schemas.microsoft.com/office/powerpoint/2010/main" val="620401284"/>
+        <p14:creationId xmlns:p14="http://schemas.microsoft.com/office/powerpoint/2010/main" val="1348808709"/>
       </p:ext>
     </p:extLst>
   </p:cSld>
@@ -5606,7 +5606,7 @@
           <p:cNvPr id="1" name="">
             <a:extLst xmlns:a="http://schemas.openxmlformats.org/drawingml/2006/main">
               <a:ext uri="{FF2B5EF4-FFF2-40B4-BE49-F238E27FC236}">
-                <a16:creationId xmlns:a16="http://schemas.microsoft.com/office/drawing/2014/main" id="{FCB9584B-FD89-4F7A-BDBC-C0C0197E212A}"/>
+                <a16:creationId xmlns:a16="http://schemas.microsoft.com/office/drawing/2014/main" id="{5AC2A277-447E-425C-882A-09F68FC8A4C6}"/>
               </a:ext>
             </a:extLst>
           </p:cNvPr>
@@ -5635,7 +5635,7 @@
           <p:cNvPr id="2" name="">
             <a:extLst xmlns:a="http://schemas.openxmlformats.org/drawingml/2006/main">
               <a:ext uri="{FF2B5EF4-FFF2-40B4-BE49-F238E27FC236}">
-                <a16:creationId xmlns:a16="http://schemas.microsoft.com/office/drawing/2014/main" id="{3CDB3DF0-B626-4B22-A1FB-D2F4531D95FD}"/>
+                <a16:creationId xmlns:a16="http://schemas.microsoft.com/office/drawing/2014/main" id="{9244BCE7-8DCF-4CC7-A482-FAB287FEED7D}"/>
               </a:ext>
             </a:extLst>
           </p:cNvPr>
@@ -5647,7 +5647,7 @@
         <p:spPr>
           <a:xfrm xmlns:a="http://schemas.openxmlformats.org/drawingml/2006/main">
             <a:off x="647700" y="361950"/>
-            <a:ext cx="4000500" cy="266700"/>
+            <a:ext cx="4953000" cy="266700"/>
           </a:xfrm>
           <a:prstGeom xmlns:a="http://schemas.openxmlformats.org/drawingml/2006/main" prst="rect">
             <a:avLst/>
@@ -5670,7 +5670,7 @@
               </a:defRPr>
             </a:pPr>
             <a:r>
-              <a:t>90-DAY PLAN</a:t>
+              <a:t>JUNE-DEC 2026 ROADMAP</a:t>
             </a:r>
           </a:p>
         </p:txBody>
@@ -5680,7 +5680,7 @@
           <p:cNvPr id="3" name="">
             <a:extLst xmlns:a="http://schemas.openxmlformats.org/drawingml/2006/main">
               <a:ext uri="{FF2B5EF4-FFF2-40B4-BE49-F238E27FC236}">
-                <a16:creationId xmlns:a16="http://schemas.microsoft.com/office/drawing/2014/main" id="{0AB0341B-1442-4F5F-BA16-BF09DA45F87D}"/>
+                <a16:creationId xmlns:a16="http://schemas.microsoft.com/office/drawing/2014/main" id="{EEC1CD95-DA0B-4B8E-BEA0-86E13B6B7068}"/>
               </a:ext>
             </a:extLst>
           </p:cNvPr>
@@ -5725,7 +5725,7 @@
           <p:cNvPr id="4" name="">
             <a:extLst xmlns:a="http://schemas.openxmlformats.org/drawingml/2006/main">
               <a:ext uri="{FF2B5EF4-FFF2-40B4-BE49-F238E27FC236}">
-                <a16:creationId xmlns:a16="http://schemas.microsoft.com/office/drawing/2014/main" id="{47E324C8-3D15-47DF-992B-C8AF14B3F630}"/>
+                <a16:creationId xmlns:a16="http://schemas.microsoft.com/office/drawing/2014/main" id="{61924A3A-12BF-43EE-83E6-CD4F250E919F}"/>
               </a:ext>
             </a:extLst>
           </p:cNvPr>
@@ -5737,7 +5737,7 @@
         <p:spPr>
           <a:xfrm xmlns:a="http://schemas.openxmlformats.org/drawingml/2006/main">
             <a:off x="457200" y="800100"/>
-            <a:ext cx="7905750" cy="876300"/>
+            <a:ext cx="8096250" cy="876300"/>
           </a:xfrm>
           <a:prstGeom xmlns:a="http://schemas.openxmlformats.org/drawingml/2006/main" prst="rect">
             <a:avLst/>
@@ -5760,7 +5760,7 @@
               </a:defRPr>
             </a:pPr>
             <a:r>
-              <a:t>Start small, prove behavior change, then institutionalize.</a:t>
+              <a:t>Start in June, prove behavior change, institutionalize by December.</a:t>
             </a:r>
           </a:p>
         </p:txBody>
@@ -5770,7 +5770,7 @@
           <p:cNvPr id="5" name="">
             <a:extLst xmlns:a="http://schemas.openxmlformats.org/drawingml/2006/main">
               <a:ext uri="{FF2B5EF4-FFF2-40B4-BE49-F238E27FC236}">
-                <a16:creationId xmlns:a16="http://schemas.microsoft.com/office/drawing/2014/main" id="{CF84F148-446D-4E7C-A462-6976A880D859}"/>
+                <a16:creationId xmlns:a16="http://schemas.microsoft.com/office/drawing/2014/main" id="{B48E9739-F0DA-465A-A1EB-C88405F3E426}"/>
               </a:ext>
             </a:extLst>
           </p:cNvPr>
@@ -5782,7 +5782,7 @@
         <p:spPr>
           <a:xfrm xmlns:a="http://schemas.openxmlformats.org/drawingml/2006/main">
             <a:off x="476250" y="1752600"/>
-            <a:ext cx="7239000" cy="533400"/>
+            <a:ext cx="7667625" cy="552450"/>
           </a:xfrm>
           <a:prstGeom xmlns:a="http://schemas.openxmlformats.org/drawingml/2006/main" prst="rect">
             <a:avLst/>
@@ -5805,7 +5805,7 @@
               </a:defRPr>
             </a:pPr>
             <a:r>
-              <a:t>A practical rollout should create visible wins without waiting for a full annual HR cycle.</a:t>
+              <a:t>The rollout creates visible wins without waiting for the annual HR or performance cycle.</a:t>
             </a:r>
           </a:p>
         </p:txBody>
@@ -5815,7 +5815,7 @@
           <p:cNvPr id="6" name="">
             <a:extLst xmlns:a="http://schemas.openxmlformats.org/drawingml/2006/main">
               <a:ext uri="{FF2B5EF4-FFF2-40B4-BE49-F238E27FC236}">
-                <a16:creationId xmlns:a16="http://schemas.microsoft.com/office/drawing/2014/main" id="{069733C5-F99B-4403-B770-C1FAECD6AD60}"/>
+                <a16:creationId xmlns:a16="http://schemas.microsoft.com/office/drawing/2014/main" id="{88CB92A4-32B4-49E6-B4FE-2D958811EE6A}"/>
               </a:ext>
             </a:extLst>
           </p:cNvPr>
@@ -5844,7 +5844,7 @@
           <p:cNvPr id="7" name="">
             <a:extLst xmlns:a="http://schemas.openxmlformats.org/drawingml/2006/main">
               <a:ext uri="{FF2B5EF4-FFF2-40B4-BE49-F238E27FC236}">
-                <a16:creationId xmlns:a16="http://schemas.microsoft.com/office/drawing/2014/main" id="{3375941E-9C4D-4DFB-BD8F-F2E5FADB674D}"/>
+                <a16:creationId xmlns:a16="http://schemas.microsoft.com/office/drawing/2014/main" id="{63EE7F21-2E21-4C51-B704-F5508A39628D}"/>
               </a:ext>
             </a:extLst>
           </p:cNvPr>
@@ -5873,7 +5873,7 @@
           <p:cNvPr id="8" name="">
             <a:extLst xmlns:a="http://schemas.openxmlformats.org/drawingml/2006/main">
               <a:ext uri="{FF2B5EF4-FFF2-40B4-BE49-F238E27FC236}">
-                <a16:creationId xmlns:a16="http://schemas.microsoft.com/office/drawing/2014/main" id="{7ECD6C4B-F0EF-42BD-A74A-29F42DA87A0A}"/>
+                <a16:creationId xmlns:a16="http://schemas.microsoft.com/office/drawing/2014/main" id="{7BD07EB8-B7D1-4BB3-90A9-6105535C2A44}"/>
               </a:ext>
             </a:extLst>
           </p:cNvPr>
@@ -5908,7 +5908,7 @@
               </a:defRPr>
             </a:pPr>
             <a:r>
-              <a:t>Days 0-30</a:t>
+              <a:t>Jun-Jul</a:t>
             </a:r>
           </a:p>
         </p:txBody>
@@ -5918,7 +5918,7 @@
           <p:cNvPr id="9" name="">
             <a:extLst xmlns:a="http://schemas.openxmlformats.org/drawingml/2006/main">
               <a:ext uri="{FF2B5EF4-FFF2-40B4-BE49-F238E27FC236}">
-                <a16:creationId xmlns:a16="http://schemas.microsoft.com/office/drawing/2014/main" id="{10160A75-6C56-4C84-8509-91D195FB38FC}"/>
+                <a16:creationId xmlns:a16="http://schemas.microsoft.com/office/drawing/2014/main" id="{9147217D-A8E3-4A3F-AAE0-919A1402F935}"/>
               </a:ext>
             </a:extLst>
           </p:cNvPr>
@@ -5963,7 +5963,7 @@
           <p:cNvPr id="10" name="">
             <a:extLst xmlns:a="http://schemas.openxmlformats.org/drawingml/2006/main">
               <a:ext uri="{FF2B5EF4-FFF2-40B4-BE49-F238E27FC236}">
-                <a16:creationId xmlns:a16="http://schemas.microsoft.com/office/drawing/2014/main" id="{93A53599-5737-4C4A-9660-296974DFC88A}"/>
+                <a16:creationId xmlns:a16="http://schemas.microsoft.com/office/drawing/2014/main" id="{26A76771-65A6-4199-90C4-C445889B7481}"/>
               </a:ext>
             </a:extLst>
           </p:cNvPr>
@@ -5998,7 +5998,7 @@
               </a:defRPr>
             </a:pPr>
             <a:r>
-              <a:t>Finalize charter, manager behavior standard, pilot functions, and first toolkit pack.</a:t>
+              <a:t>Finalize SRIB charter, manager behavior standard, pilot groups, and first toolkit pack.</a:t>
             </a:r>
           </a:p>
         </p:txBody>
@@ -6008,7 +6008,7 @@
           <p:cNvPr id="11" name="">
             <a:extLst xmlns:a="http://schemas.openxmlformats.org/drawingml/2006/main">
               <a:ext uri="{FF2B5EF4-FFF2-40B4-BE49-F238E27FC236}">
-                <a16:creationId xmlns:a16="http://schemas.microsoft.com/office/drawing/2014/main" id="{61773149-0D6F-4887-8CA7-4967479DB362}"/>
+                <a16:creationId xmlns:a16="http://schemas.microsoft.com/office/drawing/2014/main" id="{F3F52FB2-6F89-46ED-81E2-8635121E6BB4}"/>
               </a:ext>
             </a:extLst>
           </p:cNvPr>
@@ -6043,7 +6043,7 @@
               </a:defRPr>
             </a:pPr>
             <a:r>
-              <a:t>Artifact: charter + toolkit v1</a:t>
+              <a:t>Artifact: SRIB charter + toolkit v1</a:t>
             </a:r>
           </a:p>
         </p:txBody>
@@ -6053,7 +6053,7 @@
           <p:cNvPr id="12" name="">
             <a:extLst xmlns:a="http://schemas.openxmlformats.org/drawingml/2006/main">
               <a:ext uri="{FF2B5EF4-FFF2-40B4-BE49-F238E27FC236}">
-                <a16:creationId xmlns:a16="http://schemas.microsoft.com/office/drawing/2014/main" id="{77FECC0C-C535-4071-AC60-B265FD81E633}"/>
+                <a16:creationId xmlns:a16="http://schemas.microsoft.com/office/drawing/2014/main" id="{5E38369F-F789-4208-AACB-22FC5109BD71}"/>
               </a:ext>
             </a:extLst>
           </p:cNvPr>
@@ -6082,7 +6082,7 @@
           <p:cNvPr id="13" name="">
             <a:extLst xmlns:a="http://schemas.openxmlformats.org/drawingml/2006/main">
               <a:ext uri="{FF2B5EF4-FFF2-40B4-BE49-F238E27FC236}">
-                <a16:creationId xmlns:a16="http://schemas.microsoft.com/office/drawing/2014/main" id="{2C5D85D0-7504-4C0D-BF6B-F98B3F2DE694}"/>
+                <a16:creationId xmlns:a16="http://schemas.microsoft.com/office/drawing/2014/main" id="{6895AD65-421A-4988-9634-D1A8B5298495}"/>
               </a:ext>
             </a:extLst>
           </p:cNvPr>
@@ -6111,7 +6111,7 @@
           <p:cNvPr id="14" name="">
             <a:extLst xmlns:a="http://schemas.openxmlformats.org/drawingml/2006/main">
               <a:ext uri="{FF2B5EF4-FFF2-40B4-BE49-F238E27FC236}">
-                <a16:creationId xmlns:a16="http://schemas.microsoft.com/office/drawing/2014/main" id="{1C9935BA-24EA-4C37-88E4-F364653A3265}"/>
+                <a16:creationId xmlns:a16="http://schemas.microsoft.com/office/drawing/2014/main" id="{AEC74577-F23B-4FC8-A667-4EC759B6B50D}"/>
               </a:ext>
             </a:extLst>
           </p:cNvPr>
@@ -6146,7 +6146,7 @@
               </a:defRPr>
             </a:pPr>
             <a:r>
-              <a:t>Days 31-60</a:t>
+              <a:t>Aug-Sep</a:t>
             </a:r>
           </a:p>
         </p:txBody>
@@ -6156,7 +6156,7 @@
           <p:cNvPr id="15" name="">
             <a:extLst xmlns:a="http://schemas.openxmlformats.org/drawingml/2006/main">
               <a:ext uri="{FF2B5EF4-FFF2-40B4-BE49-F238E27FC236}">
-                <a16:creationId xmlns:a16="http://schemas.microsoft.com/office/drawing/2014/main" id="{F1213483-BAF8-4806-A518-C8A12DB54251}"/>
+                <a16:creationId xmlns:a16="http://schemas.microsoft.com/office/drawing/2014/main" id="{39D639A3-9086-4BC2-962A-A98F59C37E2B}"/>
               </a:ext>
             </a:extLst>
           </p:cNvPr>
@@ -6201,7 +6201,7 @@
           <p:cNvPr id="16" name="">
             <a:extLst xmlns:a="http://schemas.openxmlformats.org/drawingml/2006/main">
               <a:ext uri="{FF2B5EF4-FFF2-40B4-BE49-F238E27FC236}">
-                <a16:creationId xmlns:a16="http://schemas.microsoft.com/office/drawing/2014/main" id="{6A4A510F-87BD-4C4D-B5D5-1BCE6E22B981}"/>
+                <a16:creationId xmlns:a16="http://schemas.microsoft.com/office/drawing/2014/main" id="{B84CB6B5-F554-49BD-86EE-089B6DC82F12}"/>
               </a:ext>
             </a:extLst>
           </p:cNvPr>
@@ -6246,7 +6246,7 @@
           <p:cNvPr id="17" name="">
             <a:extLst xmlns:a="http://schemas.openxmlformats.org/drawingml/2006/main">
               <a:ext uri="{FF2B5EF4-FFF2-40B4-BE49-F238E27FC236}">
-                <a16:creationId xmlns:a16="http://schemas.microsoft.com/office/drawing/2014/main" id="{6AA11939-F520-40F5-B62B-302666209324}"/>
+                <a16:creationId xmlns:a16="http://schemas.microsoft.com/office/drawing/2014/main" id="{56B40DB1-ECFD-48AB-B97F-420BF0E6BE17}"/>
               </a:ext>
             </a:extLst>
           </p:cNvPr>
@@ -6291,7 +6291,7 @@
           <p:cNvPr id="18" name="">
             <a:extLst xmlns:a="http://schemas.openxmlformats.org/drawingml/2006/main">
               <a:ext uri="{FF2B5EF4-FFF2-40B4-BE49-F238E27FC236}">
-                <a16:creationId xmlns:a16="http://schemas.microsoft.com/office/drawing/2014/main" id="{E5DF8DA3-3BD3-4DA8-95E7-21F7376729DA}"/>
+                <a16:creationId xmlns:a16="http://schemas.microsoft.com/office/drawing/2014/main" id="{D9EAE3A4-1653-418A-8609-C22A413CDBB4}"/>
               </a:ext>
             </a:extLst>
           </p:cNvPr>
@@ -6320,7 +6320,7 @@
           <p:cNvPr id="19" name="">
             <a:extLst xmlns:a="http://schemas.openxmlformats.org/drawingml/2006/main">
               <a:ext uri="{FF2B5EF4-FFF2-40B4-BE49-F238E27FC236}">
-                <a16:creationId xmlns:a16="http://schemas.microsoft.com/office/drawing/2014/main" id="{904C0758-F517-41A3-8DB9-0E433F74AB33}"/>
+                <a16:creationId xmlns:a16="http://schemas.microsoft.com/office/drawing/2014/main" id="{AA835FF3-E77C-4FCA-89D1-21205E4471AB}"/>
               </a:ext>
             </a:extLst>
           </p:cNvPr>
@@ -6349,7 +6349,7 @@
           <p:cNvPr id="20" name="">
             <a:extLst xmlns:a="http://schemas.openxmlformats.org/drawingml/2006/main">
               <a:ext uri="{FF2B5EF4-FFF2-40B4-BE49-F238E27FC236}">
-                <a16:creationId xmlns:a16="http://schemas.microsoft.com/office/drawing/2014/main" id="{CDD0B129-0CB1-42A9-B7FD-2F91EC00A22C}"/>
+                <a16:creationId xmlns:a16="http://schemas.microsoft.com/office/drawing/2014/main" id="{AEF11E5C-09CA-44F6-AE4F-3689CF34E467}"/>
               </a:ext>
             </a:extLst>
           </p:cNvPr>
@@ -6384,7 +6384,7 @@
               </a:defRPr>
             </a:pPr>
             <a:r>
-              <a:t>Days 61-90</a:t>
+              <a:t>Oct-Dec</a:t>
             </a:r>
           </a:p>
         </p:txBody>
@@ -6394,7 +6394,7 @@
           <p:cNvPr id="21" name="">
             <a:extLst xmlns:a="http://schemas.openxmlformats.org/drawingml/2006/main">
               <a:ext uri="{FF2B5EF4-FFF2-40B4-BE49-F238E27FC236}">
-                <a16:creationId xmlns:a16="http://schemas.microsoft.com/office/drawing/2014/main" id="{C8BFB650-DBFE-4C48-929C-6E53E9A1F36F}"/>
+                <a16:creationId xmlns:a16="http://schemas.microsoft.com/office/drawing/2014/main" id="{BBCF5D04-8811-4ADC-B111-BDE92200F416}"/>
               </a:ext>
             </a:extLst>
           </p:cNvPr>
@@ -6439,7 +6439,7 @@
           <p:cNvPr id="22" name="">
             <a:extLst xmlns:a="http://schemas.openxmlformats.org/drawingml/2006/main">
               <a:ext uri="{FF2B5EF4-FFF2-40B4-BE49-F238E27FC236}">
-                <a16:creationId xmlns:a16="http://schemas.microsoft.com/office/drawing/2014/main" id="{E3AC44B1-869D-405C-A3F8-FF531144BC18}"/>
+                <a16:creationId xmlns:a16="http://schemas.microsoft.com/office/drawing/2014/main" id="{C3B5412B-82A6-4E88-810A-E23D1DD59107}"/>
               </a:ext>
             </a:extLst>
           </p:cNvPr>
@@ -6474,7 +6474,7 @@
               </a:defRPr>
             </a:pPr>
             <a:r>
-              <a:t>Refine from pulse data, train champions, publish playbook, and align with performance cycle.</a:t>
+              <a:t>Refine from pulse data, train champions, publish playbook, and align with review cycle inputs.</a:t>
             </a:r>
           </a:p>
         </p:txBody>
@@ -6484,7 +6484,7 @@
           <p:cNvPr id="23" name="">
             <a:extLst xmlns:a="http://schemas.openxmlformats.org/drawingml/2006/main">
               <a:ext uri="{FF2B5EF4-FFF2-40B4-BE49-F238E27FC236}">
-                <a16:creationId xmlns:a16="http://schemas.microsoft.com/office/drawing/2014/main" id="{85666356-16E1-46D7-8A1C-C83BF37C4A51}"/>
+                <a16:creationId xmlns:a16="http://schemas.microsoft.com/office/drawing/2014/main" id="{8C161F36-7C67-435B-B95B-C9697EC0F4E0}"/>
               </a:ext>
             </a:extLst>
           </p:cNvPr>
@@ -6519,7 +6519,7 @@
               </a:defRPr>
             </a:pPr>
             <a:r>
-              <a:t>Artifact: scale playbook</a:t>
+              <a:t>Artifact: SRIB scale playbook</a:t>
             </a:r>
           </a:p>
         </p:txBody>
@@ -6529,7 +6529,7 @@
           <p:cNvPr id="24" name="">
             <a:extLst xmlns:a="http://schemas.openxmlformats.org/drawingml/2006/main">
               <a:ext uri="{FF2B5EF4-FFF2-40B4-BE49-F238E27FC236}">
-                <a16:creationId xmlns:a16="http://schemas.microsoft.com/office/drawing/2014/main" id="{CF7A4B5D-258D-4298-AF7E-045D231EF690}"/>
+                <a16:creationId xmlns:a16="http://schemas.microsoft.com/office/drawing/2014/main" id="{ED512036-96E0-4B50-B92B-10EA60CEBDA4}"/>
               </a:ext>
             </a:extLst>
           </p:cNvPr>
@@ -6558,7 +6558,7 @@
           <p:cNvPr id="25" name="">
             <a:extLst xmlns:a="http://schemas.openxmlformats.org/drawingml/2006/main">
               <a:ext uri="{FF2B5EF4-FFF2-40B4-BE49-F238E27FC236}">
-                <a16:creationId xmlns:a16="http://schemas.microsoft.com/office/drawing/2014/main" id="{C08B42AF-2D5B-4C8B-ABC3-F907EF8941B8}"/>
+                <a16:creationId xmlns:a16="http://schemas.microsoft.com/office/drawing/2014/main" id="{FA8A60F9-F2DA-49E4-AB3C-8FE2526F31B4}"/>
               </a:ext>
             </a:extLst>
           </p:cNvPr>
@@ -6603,7 +6603,7 @@
           <p:cNvPr id="26" name="">
             <a:extLst xmlns:a="http://schemas.openxmlformats.org/drawingml/2006/main">
               <a:ext uri="{FF2B5EF4-FFF2-40B4-BE49-F238E27FC236}">
-                <a16:creationId xmlns:a16="http://schemas.microsoft.com/office/drawing/2014/main" id="{85DC9FE1-8BA0-4AAC-B4F3-011234B48E6E}"/>
+                <a16:creationId xmlns:a16="http://schemas.microsoft.com/office/drawing/2014/main" id="{47DC8BAC-4D93-4E2F-923A-356F6472D68C}"/>
               </a:ext>
             </a:extLst>
           </p:cNvPr>
@@ -6648,7 +6648,7 @@
           <p:cNvPr id="27" name="">
             <a:extLst xmlns:a="http://schemas.openxmlformats.org/drawingml/2006/main">
               <a:ext uri="{FF2B5EF4-FFF2-40B4-BE49-F238E27FC236}">
-                <a16:creationId xmlns:a16="http://schemas.microsoft.com/office/drawing/2014/main" id="{B71B037D-F8E4-4E74-9F31-004C21AA6A19}"/>
+                <a16:creationId xmlns:a16="http://schemas.microsoft.com/office/drawing/2014/main" id="{639E33B5-C2EB-4952-BA6A-B7E7FAB9349E}"/>
               </a:ext>
             </a:extLst>
           </p:cNvPr>
@@ -6677,7 +6677,7 @@
           <p:cNvPr id="28" name="">
             <a:extLst xmlns:a="http://schemas.openxmlformats.org/drawingml/2006/main">
               <a:ext uri="{FF2B5EF4-FFF2-40B4-BE49-F238E27FC236}">
-                <a16:creationId xmlns:a16="http://schemas.microsoft.com/office/drawing/2014/main" id="{94255CAC-1434-4FFE-A1CE-0EEF18912BE4}"/>
+                <a16:creationId xmlns:a16="http://schemas.microsoft.com/office/drawing/2014/main" id="{7C0E8CBA-D8D3-48EA-9149-6A8E1A049DA1}"/>
               </a:ext>
             </a:extLst>
           </p:cNvPr>
@@ -6722,7 +6722,7 @@
           <p:cNvPr id="29" name="">
             <a:extLst xmlns:a="http://schemas.openxmlformats.org/drawingml/2006/main">
               <a:ext uri="{FF2B5EF4-FFF2-40B4-BE49-F238E27FC236}">
-                <a16:creationId xmlns:a16="http://schemas.microsoft.com/office/drawing/2014/main" id="{B6E79596-D918-43F3-B722-77EEDD83B558}"/>
+                <a16:creationId xmlns:a16="http://schemas.microsoft.com/office/drawing/2014/main" id="{50BA636A-3C04-4676-845A-958F52EC6B06}"/>
               </a:ext>
             </a:extLst>
           </p:cNvPr>
@@ -6742,7 +6742,7 @@
         </p:spPr>
         <p:txBody>
           <a:bodyPr xmlns:a="http://schemas.openxmlformats.org/drawingml/2006/main" lIns="0" tIns="0" rIns="0" bIns="0">
-            <a:normAutofit fontScale="78142"/>
+            <a:normAutofit fontScale="83150"/>
           </a:bodyPr>
           <a:lstStyle xmlns:a="http://schemas.openxmlformats.org/drawingml/2006/main"/>
           <a:p xmlns:a="http://schemas.openxmlformats.org/drawingml/2006/main">
@@ -6757,7 +6757,7 @@
               </a:defRPr>
             </a:pPr>
             <a:r>
-              <a:t>Approve pilot scope, nominate leader sponsors, and authorize LMD collaboration for curriculum and toolkit build-out.</a:t>
+              <a:t>Approve SRIB pilot scope, nominate leader sponsors, and authorize LMD collaboration for June-Dec 2026 execution.</a:t>
             </a:r>
           </a:p>
         </p:txBody>
@@ -6767,7 +6767,7 @@
           <p:cNvPr id="30" name="">
             <a:extLst xmlns:a="http://schemas.openxmlformats.org/drawingml/2006/main">
               <a:ext uri="{FF2B5EF4-FFF2-40B4-BE49-F238E27FC236}">
-                <a16:creationId xmlns:a16="http://schemas.microsoft.com/office/drawing/2014/main" id="{E208BC97-529E-4743-9B75-F2C19584B115}"/>
+                <a16:creationId xmlns:a16="http://schemas.microsoft.com/office/drawing/2014/main" id="{1348223A-6A9A-4441-85EA-2F0B781244C9}"/>
               </a:ext>
             </a:extLst>
           </p:cNvPr>
@@ -6779,7 +6779,7 @@
         <p:spPr>
           <a:xfrm xmlns:a="http://schemas.openxmlformats.org/drawingml/2006/main">
             <a:off x="457200" y="6438900"/>
-            <a:ext cx="6858000" cy="171450"/>
+            <a:ext cx="7239000" cy="171450"/>
           </a:xfrm>
           <a:prstGeom xmlns:a="http://schemas.openxmlformats.org/drawingml/2006/main" prst="rect">
             <a:avLst/>
@@ -6802,7 +6802,7 @@
               </a:defRPr>
             </a:pPr>
             <a:r>
-              <a:t>Leadership Task Force | Manager Effectiveness and Everyday Leadership | Samsung India</a:t>
+              <a:t>Samsung R&amp;D Institute Bangalore | SRIB Managers and Employees | June-Dec 2026</a:t>
             </a:r>
           </a:p>
         </p:txBody>
@@ -6810,7 +6810,7 @@
     </p:spTree>
     <p:extLst>
       <p:ext uri="{BB962C8B-B14F-4D97-AF65-F5344CB8AC3E}">
-        <p14:creationId xmlns:p14="http://schemas.microsoft.com/office/powerpoint/2010/main" val="465703541"/>
+        <p14:creationId xmlns:p14="http://schemas.microsoft.com/office/powerpoint/2010/main" val="489873660"/>
       </p:ext>
     </p:extLst>
   </p:cSld>

</xml_diff>